<commit_message>
Added a paragraph to Concolusions and the presentation ppt.
</commit_message>
<xml_diff>
--- a/Paper_Presentation.pptx
+++ b/Paper_Presentation.pptx
@@ -6,7 +6,7 @@
     <p:sldMasterId id="2147483660" r:id="rId2"/>
   </p:sldMasterIdLst>
   <p:notesMasterIdLst>
-    <p:notesMasterId r:id="rId21"/>
+    <p:notesMasterId r:id="rId22"/>
   </p:notesMasterIdLst>
   <p:sldIdLst>
     <p:sldId id="256" r:id="rId6"/>
@@ -24,6 +24,7 @@
     <p:sldId id="268" r:id="rId18"/>
     <p:sldId id="269" r:id="rId19"/>
     <p:sldId id="270" r:id="rId20"/>
+    <p:sldId id="271" r:id="rId21"/>
   </p:sldIdLst>
   <p:sldSz cx="12192000" cy="6858000"/>
   <p:notesSz cx="6858000" cy="9144000"/>
@@ -149,7 +150,7 @@
       </p:grpSpPr>
       <p:sp>
         <p:nvSpPr>
-          <p:cNvPr id="812647705" name="Header Placeholder 1"/>
+          <p:cNvPr id="460111932" name="Header Placeholder 1"/>
           <p:cNvSpPr>
             <a:spLocks noGrp="1"/>
           </p:cNvSpPr>
@@ -183,7 +184,7 @@
       </p:sp>
       <p:sp>
         <p:nvSpPr>
-          <p:cNvPr id="1782414062" name="Date Placeholder 2"/>
+          <p:cNvPr id="70310210" name="Date Placeholder 2"/>
           <p:cNvSpPr>
             <a:spLocks noGrp="1"/>
           </p:cNvSpPr>
@@ -221,7 +222,7 @@
       </p:sp>
       <p:sp>
         <p:nvSpPr>
-          <p:cNvPr id="1381563699" name="Slide Image Placeholder 3"/>
+          <p:cNvPr id="943326989" name="Slide Image Placeholder 3"/>
           <p:cNvSpPr>
             <a:spLocks noChangeAspect="1" noGrp="1" noRot="1"/>
           </p:cNvSpPr>
@@ -257,7 +258,7 @@
       </p:sp>
       <p:sp>
         <p:nvSpPr>
-          <p:cNvPr id="904129163" name="Notes Placeholder 4"/>
+          <p:cNvPr id="679240481" name="Notes Placeholder 4"/>
           <p:cNvSpPr>
             <a:spLocks noGrp="1"/>
           </p:cNvSpPr>
@@ -331,7 +332,7 @@
       </p:sp>
       <p:sp>
         <p:nvSpPr>
-          <p:cNvPr id="1920779020" name="Footer Placeholder 5"/>
+          <p:cNvPr id="306723329" name="Footer Placeholder 5"/>
           <p:cNvSpPr>
             <a:spLocks noGrp="1"/>
           </p:cNvSpPr>
@@ -365,7 +366,7 @@
       </p:sp>
       <p:sp>
         <p:nvSpPr>
-          <p:cNvPr id="1533183697" name="Slide Number Placeholder 6"/>
+          <p:cNvPr id="1295748975" name="Slide Number Placeholder 6"/>
           <p:cNvSpPr>
             <a:spLocks noGrp="1"/>
           </p:cNvSpPr>
@@ -404,6 +405,7 @@
     </p:spTree>
   </p:cSld>
   <p:clrMap bg1="lt1" tx1="dk1" bg2="lt2" tx2="dk2" accent1="accent1" accent2="accent2" accent3="accent3" accent4="accent4" accent5="accent5" accent6="accent6" hlink="hlink" folHlink="folHlink"/>
+  <p:hf dt="0" ftr="0" hdr="0" sldNum="1"/>
   <p:notesStyle>
     <a:lvl1pPr marL="0" algn="l" defTabSz="914400">
       <a:defRPr sz="1200">
@@ -518,7 +520,7 @@
       </p:grpSpPr>
       <p:sp>
         <p:nvSpPr>
-          <p:cNvPr id="1247806186" name="Slide Image Placeholder 1"/>
+          <p:cNvPr id="2013829671" name="Slide Image Placeholder 1"/>
           <p:cNvSpPr>
             <a:spLocks noChangeAspect="1" noGrp="1" noRot="1"/>
           </p:cNvSpPr>
@@ -535,7 +537,7 @@
       </p:sp>
       <p:sp>
         <p:nvSpPr>
-          <p:cNvPr id="131471702" name="Notes Placeholder 2"/>
+          <p:cNvPr id="1218010910" name="Notes Placeholder 2"/>
           <p:cNvSpPr>
             <a:spLocks noGrp="1"/>
           </p:cNvSpPr>
@@ -560,7 +562,7 @@
       </p:sp>
       <p:sp>
         <p:nvSpPr>
-          <p:cNvPr id="1933656048" name="Slide Number Placeholder 3"/>
+          <p:cNvPr id="30406700" name="Slide Number Placeholder 3"/>
           <p:cNvSpPr>
             <a:spLocks noGrp="1"/>
           </p:cNvSpPr>
@@ -611,7 +613,7 @@
       </p:grpSpPr>
       <p:sp>
         <p:nvSpPr>
-          <p:cNvPr id="1474187631" name="Slide Image Placeholder 1"/>
+          <p:cNvPr id="76914265" name="Slide Image Placeholder 1"/>
           <p:cNvSpPr>
             <a:spLocks noChangeAspect="1" noGrp="1" noRot="1"/>
           </p:cNvSpPr>
@@ -623,7 +625,7 @@
       </p:sp>
       <p:sp>
         <p:nvSpPr>
-          <p:cNvPr id="1346109639" name="Notes Placeholder 2"/>
+          <p:cNvPr id="1588131331" name="Notes Placeholder 2"/>
           <p:cNvSpPr>
             <a:spLocks noGrp="1"/>
           </p:cNvSpPr>
@@ -645,7 +647,7 @@
       </p:sp>
       <p:sp>
         <p:nvSpPr>
-          <p:cNvPr id="1727368739" name="Slide Number Placeholder 3"/>
+          <p:cNvPr id="1483746294" name="Slide Number Placeholder 3"/>
           <p:cNvSpPr>
             <a:spLocks noGrp="1"/>
           </p:cNvSpPr>
@@ -661,7 +663,7 @@
             <a:pPr>
               <a:defRPr/>
             </a:pPr>
-            <a:fld id="{8A2F8A38-3197-84E2-41F8-800D35B74611}" type="slidenum">
+            <a:fld id="{A1A8E283-2BF5-EAC5-AEEA-D20448F4A19B}" type="slidenum">
               <a:rPr/>
               <a:t/>
             </a:fld>
@@ -696,7 +698,7 @@
       </p:grpSpPr>
       <p:sp>
         <p:nvSpPr>
-          <p:cNvPr id="1616062698" name="Slide Image Placeholder 1"/>
+          <p:cNvPr id="1916978031" name="Slide Image Placeholder 1"/>
           <p:cNvSpPr>
             <a:spLocks noChangeAspect="1" noGrp="1" noRot="1"/>
           </p:cNvSpPr>
@@ -708,7 +710,7 @@
       </p:sp>
       <p:sp>
         <p:nvSpPr>
-          <p:cNvPr id="35418697" name="Notes Placeholder 2"/>
+          <p:cNvPr id="670724564" name="Notes Placeholder 2"/>
           <p:cNvSpPr>
             <a:spLocks noGrp="1"/>
           </p:cNvSpPr>
@@ -730,7 +732,7 @@
       </p:sp>
       <p:sp>
         <p:nvSpPr>
-          <p:cNvPr id="864908100" name="Slide Number Placeholder 3"/>
+          <p:cNvPr id="348088939" name="Slide Number Placeholder 3"/>
           <p:cNvSpPr>
             <a:spLocks noGrp="1"/>
           </p:cNvSpPr>
@@ -746,7 +748,7 @@
             <a:pPr>
               <a:defRPr/>
             </a:pPr>
-            <a:fld id="{5FE1277E-B386-2D1C-07DD-B512FE854624}" type="slidenum">
+            <a:fld id="{8A2F8A38-3197-84E2-41F8-800D35B74611}" type="slidenum">
               <a:rPr/>
               <a:t/>
             </a:fld>
@@ -781,7 +783,7 @@
       </p:grpSpPr>
       <p:sp>
         <p:nvSpPr>
-          <p:cNvPr id="807059526" name="Slide Image Placeholder 1"/>
+          <p:cNvPr id="1832361576" name="Slide Image Placeholder 1"/>
           <p:cNvSpPr>
             <a:spLocks noChangeAspect="1" noGrp="1" noRot="1"/>
           </p:cNvSpPr>
@@ -793,7 +795,7 @@
       </p:sp>
       <p:sp>
         <p:nvSpPr>
-          <p:cNvPr id="1808378063" name="Notes Placeholder 2"/>
+          <p:cNvPr id="348881597" name="Notes Placeholder 2"/>
           <p:cNvSpPr>
             <a:spLocks noGrp="1"/>
           </p:cNvSpPr>
@@ -815,7 +817,7 @@
       </p:sp>
       <p:sp>
         <p:nvSpPr>
-          <p:cNvPr id="2037631809" name="Slide Number Placeholder 3"/>
+          <p:cNvPr id="499165186" name="Slide Number Placeholder 3"/>
           <p:cNvSpPr>
             <a:spLocks noGrp="1"/>
           </p:cNvSpPr>
@@ -831,7 +833,7 @@
             <a:pPr>
               <a:defRPr/>
             </a:pPr>
-            <a:fld id="{8F3616E4-51A7-3293-9D8F-E65667A5F191}" type="slidenum">
+            <a:fld id="{5FE1277E-B386-2D1C-07DD-B512FE854624}" type="slidenum">
               <a:rPr/>
               <a:t/>
             </a:fld>
@@ -866,7 +868,7 @@
       </p:grpSpPr>
       <p:sp>
         <p:nvSpPr>
-          <p:cNvPr id="1178674632" name="Slide Image Placeholder 1"/>
+          <p:cNvPr id="2113514036" name="Slide Image Placeholder 1"/>
           <p:cNvSpPr>
             <a:spLocks noChangeAspect="1" noGrp="1" noRot="1"/>
           </p:cNvSpPr>
@@ -878,7 +880,7 @@
       </p:sp>
       <p:sp>
         <p:nvSpPr>
-          <p:cNvPr id="63072158" name="Notes Placeholder 2"/>
+          <p:cNvPr id="1901777287" name="Notes Placeholder 2"/>
           <p:cNvSpPr>
             <a:spLocks noGrp="1"/>
           </p:cNvSpPr>
@@ -900,7 +902,7 @@
       </p:sp>
       <p:sp>
         <p:nvSpPr>
-          <p:cNvPr id="302739547" name="Slide Number Placeholder 3"/>
+          <p:cNvPr id="1540599595" name="Slide Number Placeholder 3"/>
           <p:cNvSpPr>
             <a:spLocks noGrp="1"/>
           </p:cNvSpPr>
@@ -916,7 +918,7 @@
             <a:pPr>
               <a:defRPr/>
             </a:pPr>
-            <a:fld id="{D1D38BC4-C35B-5B13-4107-52AA3E575674}" type="slidenum">
+            <a:fld id="{8F3616E4-51A7-3293-9D8F-E65667A5F191}" type="slidenum">
               <a:rPr/>
               <a:t/>
             </a:fld>
@@ -951,7 +953,7 @@
       </p:grpSpPr>
       <p:sp>
         <p:nvSpPr>
-          <p:cNvPr id="189713187" name="Slide Image Placeholder 1"/>
+          <p:cNvPr id="1134107857" name="Slide Image Placeholder 1"/>
           <p:cNvSpPr>
             <a:spLocks noChangeAspect="1" noGrp="1" noRot="1"/>
           </p:cNvSpPr>
@@ -963,7 +965,7 @@
       </p:sp>
       <p:sp>
         <p:nvSpPr>
-          <p:cNvPr id="1115039826" name="Notes Placeholder 2"/>
+          <p:cNvPr id="948826324" name="Notes Placeholder 2"/>
           <p:cNvSpPr>
             <a:spLocks noGrp="1"/>
           </p:cNvSpPr>
@@ -985,7 +987,7 @@
       </p:sp>
       <p:sp>
         <p:nvSpPr>
-          <p:cNvPr id="1264320193" name="Slide Number Placeholder 3"/>
+          <p:cNvPr id="670631594" name="Slide Number Placeholder 3"/>
           <p:cNvSpPr>
             <a:spLocks noGrp="1"/>
           </p:cNvSpPr>
@@ -1001,7 +1003,7 @@
             <a:pPr>
               <a:defRPr/>
             </a:pPr>
-            <a:fld id="{5D4DCAD6-CC46-D072-C7F3-848636E3B326}" type="slidenum">
+            <a:fld id="{D1D38BC4-C35B-5B13-4107-52AA3E575674}" type="slidenum">
               <a:rPr/>
               <a:t/>
             </a:fld>
@@ -1036,7 +1038,7 @@
       </p:grpSpPr>
       <p:sp>
         <p:nvSpPr>
-          <p:cNvPr id="651762471" name="Slide Image Placeholder 1"/>
+          <p:cNvPr id="896041629" name="Slide Image Placeholder 1"/>
           <p:cNvSpPr>
             <a:spLocks noChangeAspect="1" noGrp="1" noRot="1"/>
           </p:cNvSpPr>
@@ -1048,7 +1050,7 @@
       </p:sp>
       <p:sp>
         <p:nvSpPr>
-          <p:cNvPr id="412864840" name="Notes Placeholder 2"/>
+          <p:cNvPr id="82768400" name="Notes Placeholder 2"/>
           <p:cNvSpPr>
             <a:spLocks noGrp="1"/>
           </p:cNvSpPr>
@@ -1070,7 +1072,92 @@
       </p:sp>
       <p:sp>
         <p:nvSpPr>
-          <p:cNvPr id="1068419690" name="Slide Number Placeholder 3"/>
+          <p:cNvPr id="199110807" name="Slide Number Placeholder 3"/>
+          <p:cNvSpPr>
+            <a:spLocks noGrp="1"/>
+          </p:cNvSpPr>
+          <p:nvPr>
+            <p:ph type="sldNum" sz="quarter" idx="10"/>
+          </p:nvPr>
+        </p:nvSpPr>
+        <p:spPr bwMode="auto"/>
+        <p:txBody>
+          <a:bodyPr/>
+          <a:lstStyle/>
+          <a:p>
+            <a:pPr>
+              <a:defRPr/>
+            </a:pPr>
+            <a:fld id="{5D4DCAD6-CC46-D072-C7F3-848636E3B326}" type="slidenum">
+              <a:rPr/>
+              <a:t/>
+            </a:fld>
+            <a:endParaRPr/>
+          </a:p>
+        </p:txBody>
+      </p:sp>
+    </p:spTree>
+  </p:cSld>
+  <p:clrMapOvr>
+    <a:masterClrMapping/>
+  </p:clrMapOvr>
+</p:notes>
+</file>
+
+<file path=ppt/notesSlides/notesSlide16.xml><?xml version="1.0" encoding="utf-8"?>
+<p:notes xmlns:a="http://schemas.openxmlformats.org/drawingml/2006/main" xmlns:r="http://schemas.openxmlformats.org/officeDocument/2006/relationships" xmlns:p="http://schemas.openxmlformats.org/presentationml/2006/main" xmlns:m="http://schemas.openxmlformats.org/officeDocument/2006/math" xmlns:w="http://schemas.openxmlformats.org/wordprocessingml/2006/main">
+  <p:cSld name="">
+    <p:spTree>
+      <p:nvGrpSpPr>
+        <p:cNvPr id="1" name=""/>
+        <p:cNvGrpSpPr/>
+        <p:nvPr/>
+      </p:nvGrpSpPr>
+      <p:grpSpPr bwMode="auto">
+        <a:xfrm>
+          <a:off x="0" y="0"/>
+          <a:ext cx="0" cy="0"/>
+          <a:chOff x="0" y="0"/>
+          <a:chExt cx="0" cy="0"/>
+        </a:xfrm>
+      </p:grpSpPr>
+      <p:sp>
+        <p:nvSpPr>
+          <p:cNvPr id="1997724546" name="Slide Image Placeholder 1"/>
+          <p:cNvSpPr>
+            <a:spLocks noChangeAspect="1" noGrp="1" noRot="1"/>
+          </p:cNvSpPr>
+          <p:nvPr>
+            <p:ph type="sldImg"/>
+          </p:nvPr>
+        </p:nvSpPr>
+        <p:spPr bwMode="auto"/>
+      </p:sp>
+      <p:sp>
+        <p:nvSpPr>
+          <p:cNvPr id="1655841881" name="Notes Placeholder 2"/>
+          <p:cNvSpPr>
+            <a:spLocks noGrp="1"/>
+          </p:cNvSpPr>
+          <p:nvPr>
+            <p:ph type="body" idx="1"/>
+          </p:nvPr>
+        </p:nvSpPr>
+        <p:spPr bwMode="auto"/>
+        <p:txBody>
+          <a:bodyPr/>
+          <a:lstStyle/>
+          <a:p>
+            <a:pPr>
+              <a:defRPr/>
+            </a:pPr>
+            <a:endParaRPr/>
+          </a:p>
+        </p:txBody>
+      </p:sp>
+      <p:sp>
+        <p:nvSpPr>
+          <p:cNvPr id="1374932086" name="Slide Number Placeholder 3"/>
           <p:cNvSpPr>
             <a:spLocks noGrp="1"/>
           </p:cNvSpPr>
@@ -1121,7 +1208,7 @@
       </p:grpSpPr>
       <p:sp>
         <p:nvSpPr>
-          <p:cNvPr id="1834681690" name="Slide Image Placeholder 1"/>
+          <p:cNvPr id="1574473906" name="Slide Image Placeholder 1"/>
           <p:cNvSpPr>
             <a:spLocks noChangeAspect="1" noGrp="1" noRot="1"/>
           </p:cNvSpPr>
@@ -1133,7 +1220,7 @@
       </p:sp>
       <p:sp>
         <p:nvSpPr>
-          <p:cNvPr id="1289769263" name="Notes Placeholder 2"/>
+          <p:cNvPr id="1415569192" name="Notes Placeholder 2"/>
           <p:cNvSpPr>
             <a:spLocks noGrp="1"/>
           </p:cNvSpPr>
@@ -1155,7 +1242,7 @@
       </p:sp>
       <p:sp>
         <p:nvSpPr>
-          <p:cNvPr id="1019048670" name="Slide Number Placeholder 3"/>
+          <p:cNvPr id="85820569" name="Slide Number Placeholder 3"/>
           <p:cNvSpPr>
             <a:spLocks noGrp="1"/>
           </p:cNvSpPr>
@@ -1206,7 +1293,7 @@
       </p:grpSpPr>
       <p:sp>
         <p:nvSpPr>
-          <p:cNvPr id="1788825862" name="Slide Image Placeholder 1"/>
+          <p:cNvPr id="456655036" name="Slide Image Placeholder 1"/>
           <p:cNvSpPr>
             <a:spLocks noChangeAspect="1" noGrp="1" noRot="1"/>
           </p:cNvSpPr>
@@ -1218,7 +1305,7 @@
       </p:sp>
       <p:sp>
         <p:nvSpPr>
-          <p:cNvPr id="1944700265" name="Notes Placeholder 2"/>
+          <p:cNvPr id="510627461" name="Notes Placeholder 2"/>
           <p:cNvSpPr>
             <a:spLocks noGrp="1"/>
           </p:cNvSpPr>
@@ -1240,7 +1327,7 @@
       </p:sp>
       <p:sp>
         <p:nvSpPr>
-          <p:cNvPr id="754034568" name="Slide Number Placeholder 3"/>
+          <p:cNvPr id="490426299" name="Slide Number Placeholder 3"/>
           <p:cNvSpPr>
             <a:spLocks noGrp="1"/>
           </p:cNvSpPr>
@@ -1291,7 +1378,7 @@
       </p:grpSpPr>
       <p:sp>
         <p:nvSpPr>
-          <p:cNvPr id="1298940374" name="Slide Image Placeholder 1"/>
+          <p:cNvPr id="1165753131" name="Slide Image Placeholder 1"/>
           <p:cNvSpPr>
             <a:spLocks noChangeAspect="1" noGrp="1" noRot="1"/>
           </p:cNvSpPr>
@@ -1303,7 +1390,7 @@
       </p:sp>
       <p:sp>
         <p:nvSpPr>
-          <p:cNvPr id="1127564572" name="Notes Placeholder 2"/>
+          <p:cNvPr id="329967727" name="Notes Placeholder 2"/>
           <p:cNvSpPr>
             <a:spLocks noGrp="1"/>
           </p:cNvSpPr>
@@ -1325,7 +1412,7 @@
       </p:sp>
       <p:sp>
         <p:nvSpPr>
-          <p:cNvPr id="167838776" name="Slide Number Placeholder 3"/>
+          <p:cNvPr id="1038208206" name="Slide Number Placeholder 3"/>
           <p:cNvSpPr>
             <a:spLocks noGrp="1"/>
           </p:cNvSpPr>
@@ -1376,7 +1463,7 @@
       </p:grpSpPr>
       <p:sp>
         <p:nvSpPr>
-          <p:cNvPr id="1453768802" name="Slide Image Placeholder 1"/>
+          <p:cNvPr id="2144207912" name="Slide Image Placeholder 1"/>
           <p:cNvSpPr>
             <a:spLocks noChangeAspect="1" noGrp="1" noRot="1"/>
           </p:cNvSpPr>
@@ -1388,7 +1475,7 @@
       </p:sp>
       <p:sp>
         <p:nvSpPr>
-          <p:cNvPr id="2004094392" name="Notes Placeholder 2"/>
+          <p:cNvPr id="1302798311" name="Notes Placeholder 2"/>
           <p:cNvSpPr>
             <a:spLocks noGrp="1"/>
           </p:cNvSpPr>
@@ -1410,7 +1497,7 @@
       </p:sp>
       <p:sp>
         <p:nvSpPr>
-          <p:cNvPr id="832629927" name="Slide Number Placeholder 3"/>
+          <p:cNvPr id="1029134919" name="Slide Number Placeholder 3"/>
           <p:cNvSpPr>
             <a:spLocks noGrp="1"/>
           </p:cNvSpPr>
@@ -1461,7 +1548,7 @@
       </p:grpSpPr>
       <p:sp>
         <p:nvSpPr>
-          <p:cNvPr id="2077301892" name="Slide Image Placeholder 1"/>
+          <p:cNvPr id="1585308063" name="Slide Image Placeholder 1"/>
           <p:cNvSpPr>
             <a:spLocks noChangeAspect="1" noGrp="1" noRot="1"/>
           </p:cNvSpPr>
@@ -1473,7 +1560,7 @@
       </p:sp>
       <p:sp>
         <p:nvSpPr>
-          <p:cNvPr id="1580386069" name="Notes Placeholder 2"/>
+          <p:cNvPr id="228812792" name="Notes Placeholder 2"/>
           <p:cNvSpPr>
             <a:spLocks noGrp="1"/>
           </p:cNvSpPr>
@@ -1495,7 +1582,7 @@
       </p:sp>
       <p:sp>
         <p:nvSpPr>
-          <p:cNvPr id="309818884" name="Slide Number Placeholder 3"/>
+          <p:cNvPr id="830985693" name="Slide Number Placeholder 3"/>
           <p:cNvSpPr>
             <a:spLocks noGrp="1"/>
           </p:cNvSpPr>
@@ -1546,7 +1633,7 @@
       </p:grpSpPr>
       <p:sp>
         <p:nvSpPr>
-          <p:cNvPr id="512463688" name="Slide Image Placeholder 1"/>
+          <p:cNvPr id="1912791749" name="Slide Image Placeholder 1"/>
           <p:cNvSpPr>
             <a:spLocks noChangeAspect="1" noGrp="1" noRot="1"/>
           </p:cNvSpPr>
@@ -1558,7 +1645,7 @@
       </p:sp>
       <p:sp>
         <p:nvSpPr>
-          <p:cNvPr id="1802698364" name="Notes Placeholder 2"/>
+          <p:cNvPr id="1940576378" name="Notes Placeholder 2"/>
           <p:cNvSpPr>
             <a:spLocks noGrp="1"/>
           </p:cNvSpPr>
@@ -1580,7 +1667,7 @@
       </p:sp>
       <p:sp>
         <p:nvSpPr>
-          <p:cNvPr id="1831386381" name="Slide Number Placeholder 3"/>
+          <p:cNvPr id="1090902194" name="Slide Number Placeholder 3"/>
           <p:cNvSpPr>
             <a:spLocks noGrp="1"/>
           </p:cNvSpPr>
@@ -1631,7 +1718,7 @@
       </p:grpSpPr>
       <p:sp>
         <p:nvSpPr>
-          <p:cNvPr id="712743368" name="Slide Image Placeholder 1"/>
+          <p:cNvPr id="516448639" name="Slide Image Placeholder 1"/>
           <p:cNvSpPr>
             <a:spLocks noChangeAspect="1" noGrp="1" noRot="1"/>
           </p:cNvSpPr>
@@ -1643,7 +1730,7 @@
       </p:sp>
       <p:sp>
         <p:nvSpPr>
-          <p:cNvPr id="178695099" name="Notes Placeholder 2"/>
+          <p:cNvPr id="310770583" name="Notes Placeholder 2"/>
           <p:cNvSpPr>
             <a:spLocks noGrp="1"/>
           </p:cNvSpPr>
@@ -1665,7 +1752,7 @@
       </p:sp>
       <p:sp>
         <p:nvSpPr>
-          <p:cNvPr id="528349766" name="Slide Number Placeholder 3"/>
+          <p:cNvPr id="1681755666" name="Slide Number Placeholder 3"/>
           <p:cNvSpPr>
             <a:spLocks noGrp="1"/>
           </p:cNvSpPr>
@@ -1716,7 +1803,7 @@
       </p:grpSpPr>
       <p:sp>
         <p:nvSpPr>
-          <p:cNvPr id="1994906966" name="Slide Image Placeholder 1"/>
+          <p:cNvPr id="971963127" name="Slide Image Placeholder 1"/>
           <p:cNvSpPr>
             <a:spLocks noChangeAspect="1" noGrp="1" noRot="1"/>
           </p:cNvSpPr>
@@ -1728,7 +1815,7 @@
       </p:sp>
       <p:sp>
         <p:nvSpPr>
-          <p:cNvPr id="914694419" name="Notes Placeholder 2"/>
+          <p:cNvPr id="1128932189" name="Notes Placeholder 2"/>
           <p:cNvSpPr>
             <a:spLocks noGrp="1"/>
           </p:cNvSpPr>
@@ -1750,7 +1837,7 @@
       </p:sp>
       <p:sp>
         <p:nvSpPr>
-          <p:cNvPr id="656400348" name="Slide Number Placeholder 3"/>
+          <p:cNvPr id="1737023105" name="Slide Number Placeholder 3"/>
           <p:cNvSpPr>
             <a:spLocks noGrp="1"/>
           </p:cNvSpPr>
@@ -1766,7 +1853,7 @@
             <a:pPr>
               <a:defRPr/>
             </a:pPr>
-            <a:fld id="{A1A8E283-2BF5-EAC5-AEEA-D20448F4A19B}" type="slidenum">
+            <a:fld id="{0220DD1E-0269-5C0A-5B9C-789A512B0091}" type="slidenum">
               <a:rPr/>
               <a:t/>
             </a:fld>
@@ -1801,7 +1888,7 @@
       </p:grpSpPr>
       <p:sp>
         <p:nvSpPr>
-          <p:cNvPr id="1418412078" name="Title 1"/>
+          <p:cNvPr id="1498141711" name="Title 1"/>
           <p:cNvSpPr>
             <a:spLocks noGrp="1"/>
           </p:cNvSpPr>
@@ -1842,7 +1929,7 @@
       </p:sp>
       <p:sp>
         <p:nvSpPr>
-          <p:cNvPr id="938807460" name="Subtitle 2"/>
+          <p:cNvPr id="1109805416" name="Subtitle 2"/>
           <p:cNvSpPr>
             <a:spLocks noGrp="1"/>
           </p:cNvSpPr>
@@ -1966,7 +2053,7 @@
       </p:sp>
       <p:sp>
         <p:nvSpPr>
-          <p:cNvPr id="290935884" name="Date Placeholder 14"/>
+          <p:cNvPr id="1083148552" name="Date Placeholder 14"/>
           <p:cNvSpPr>
             <a:spLocks noGrp="1"/>
           </p:cNvSpPr>
@@ -1992,7 +2079,7 @@
       </p:sp>
       <p:sp>
         <p:nvSpPr>
-          <p:cNvPr id="555374277" name="Footer Placeholder 15"/>
+          <p:cNvPr id="100341018" name="Footer Placeholder 15"/>
           <p:cNvSpPr>
             <a:spLocks noGrp="1"/>
           </p:cNvSpPr>
@@ -2014,7 +2101,7 @@
       </p:sp>
       <p:sp>
         <p:nvSpPr>
-          <p:cNvPr id="70399186" name="Slide Number Placeholder 17"/>
+          <p:cNvPr id="1443642819" name="Slide Number Placeholder 17"/>
           <p:cNvSpPr>
             <a:spLocks noGrp="1"/>
           </p:cNvSpPr>
@@ -2040,7 +2127,7 @@
       </p:sp>
       <p:grpSp>
         <p:nvGrpSpPr>
-          <p:cNvPr id="91513193" name="Group 312"/>
+          <p:cNvPr id="1491294977" name="Group 312"/>
           <p:cNvGrpSpPr/>
           <p:nvPr userDrawn="1"/>
         </p:nvGrpSpPr>
@@ -3464,7 +3551,7 @@
       </p:grpSp>
       <p:grpSp>
         <p:nvGrpSpPr>
-          <p:cNvPr id="94767174" name="Group 4"/>
+          <p:cNvPr id="725258687" name="Group 4"/>
           <p:cNvGrpSpPr/>
           <p:nvPr userDrawn="1"/>
         </p:nvGrpSpPr>
@@ -4077,7 +4164,7 @@
       </p:grpSpPr>
       <p:sp>
         <p:nvSpPr>
-          <p:cNvPr id="579378786" name="Title 1"/>
+          <p:cNvPr id="1277502055" name="Title 1"/>
           <p:cNvSpPr>
             <a:spLocks noGrp="1"/>
           </p:cNvSpPr>
@@ -4103,7 +4190,7 @@
       </p:sp>
       <p:sp>
         <p:nvSpPr>
-          <p:cNvPr id="1061658414" name="Vertical Text Placeholder 2"/>
+          <p:cNvPr id="552269931" name="Vertical Text Placeholder 2"/>
           <p:cNvSpPr>
             <a:spLocks noGrp="1"/>
           </p:cNvSpPr>
@@ -4169,7 +4256,7 @@
       </p:sp>
       <p:sp>
         <p:nvSpPr>
-          <p:cNvPr id="423439623" name="Date Placeholder 9"/>
+          <p:cNvPr id="2143508896" name="Date Placeholder 9"/>
           <p:cNvSpPr>
             <a:spLocks noGrp="1"/>
           </p:cNvSpPr>
@@ -4195,7 +4282,7 @@
       </p:sp>
       <p:sp>
         <p:nvSpPr>
-          <p:cNvPr id="2060398966" name="Footer Placeholder 10"/>
+          <p:cNvPr id="1711458986" name="Footer Placeholder 10"/>
           <p:cNvSpPr>
             <a:spLocks noGrp="1"/>
           </p:cNvSpPr>
@@ -4217,7 +4304,7 @@
       </p:sp>
       <p:sp>
         <p:nvSpPr>
-          <p:cNvPr id="1102000742" name="Slide Number Placeholder 11"/>
+          <p:cNvPr id="1538814445" name="Slide Number Placeholder 11"/>
           <p:cNvSpPr>
             <a:spLocks noGrp="1"/>
           </p:cNvSpPr>
@@ -4268,7 +4355,7 @@
       </p:grpSpPr>
       <p:sp>
         <p:nvSpPr>
-          <p:cNvPr id="72487757" name="Vertical Title 1"/>
+          <p:cNvPr id="2080328683" name="Vertical Title 1"/>
           <p:cNvSpPr>
             <a:spLocks noGrp="1"/>
           </p:cNvSpPr>
@@ -4303,7 +4390,7 @@
       </p:sp>
       <p:sp>
         <p:nvSpPr>
-          <p:cNvPr id="1321484435" name="Vertical Text Placeholder 2"/>
+          <p:cNvPr id="2119089023" name="Vertical Text Placeholder 2"/>
           <p:cNvSpPr>
             <a:spLocks noGrp="1"/>
           </p:cNvSpPr>
@@ -4374,7 +4461,7 @@
       </p:sp>
       <p:sp>
         <p:nvSpPr>
-          <p:cNvPr id="432831309" name="Date Placeholder 9"/>
+          <p:cNvPr id="1265102019" name="Date Placeholder 9"/>
           <p:cNvSpPr>
             <a:spLocks noGrp="1"/>
           </p:cNvSpPr>
@@ -4400,7 +4487,7 @@
       </p:sp>
       <p:sp>
         <p:nvSpPr>
-          <p:cNvPr id="2064213754" name="Footer Placeholder 10"/>
+          <p:cNvPr id="335639753" name="Footer Placeholder 10"/>
           <p:cNvSpPr>
             <a:spLocks noGrp="1"/>
           </p:cNvSpPr>
@@ -4422,7 +4509,7 @@
       </p:sp>
       <p:sp>
         <p:nvSpPr>
-          <p:cNvPr id="993607898" name="Slide Number Placeholder 11"/>
+          <p:cNvPr id="1412316708" name="Slide Number Placeholder 11"/>
           <p:cNvSpPr>
             <a:spLocks noGrp="1"/>
           </p:cNvSpPr>
@@ -4473,7 +4560,7 @@
       </p:grpSpPr>
       <p:sp>
         <p:nvSpPr>
-          <p:cNvPr id="1377453954" name="Title 1"/>
+          <p:cNvPr id="1237491815" name="Title 1"/>
           <p:cNvSpPr>
             <a:spLocks noGrp="1"/>
           </p:cNvSpPr>
@@ -4514,7 +4601,7 @@
       </p:sp>
       <p:sp>
         <p:nvSpPr>
-          <p:cNvPr id="1498354594" name="Subtitle 2"/>
+          <p:cNvPr id="1652396509" name="Subtitle 2"/>
           <p:cNvSpPr>
             <a:spLocks noGrp="1"/>
           </p:cNvSpPr>
@@ -4638,7 +4725,7 @@
       </p:sp>
       <p:sp>
         <p:nvSpPr>
-          <p:cNvPr id="2048686872" name="Date Placeholder 14"/>
+          <p:cNvPr id="745153610" name="Date Placeholder 14"/>
           <p:cNvSpPr>
             <a:spLocks noGrp="1"/>
           </p:cNvSpPr>
@@ -4664,7 +4751,7 @@
       </p:sp>
       <p:sp>
         <p:nvSpPr>
-          <p:cNvPr id="1530171193" name="Footer Placeholder 15"/>
+          <p:cNvPr id="632448502" name="Footer Placeholder 15"/>
           <p:cNvSpPr>
             <a:spLocks noGrp="1"/>
           </p:cNvSpPr>
@@ -4686,7 +4773,7 @@
       </p:sp>
       <p:sp>
         <p:nvSpPr>
-          <p:cNvPr id="1565027121" name="Slide Number Placeholder 17"/>
+          <p:cNvPr id="139198618" name="Slide Number Placeholder 17"/>
           <p:cNvSpPr>
             <a:spLocks noGrp="1"/>
           </p:cNvSpPr>
@@ -4712,7 +4799,7 @@
       </p:sp>
       <p:grpSp>
         <p:nvGrpSpPr>
-          <p:cNvPr id="1753553243" name="Group 312"/>
+          <p:cNvPr id="1930091273" name="Group 312"/>
           <p:cNvGrpSpPr/>
           <p:nvPr userDrawn="1"/>
         </p:nvGrpSpPr>
@@ -6136,7 +6223,7 @@
       </p:grpSp>
       <p:grpSp>
         <p:nvGrpSpPr>
-          <p:cNvPr id="1547212783" name="Group 4"/>
+          <p:cNvPr id="1460042937" name="Group 4"/>
           <p:cNvGrpSpPr/>
           <p:nvPr userDrawn="1"/>
         </p:nvGrpSpPr>
@@ -6749,7 +6836,7 @@
       </p:grpSpPr>
       <p:sp>
         <p:nvSpPr>
-          <p:cNvPr id="337511257" name="Title 1"/>
+          <p:cNvPr id="502893800" name="Title 1"/>
           <p:cNvSpPr>
             <a:spLocks noGrp="1"/>
           </p:cNvSpPr>
@@ -6775,7 +6862,7 @@
       </p:sp>
       <p:sp>
         <p:nvSpPr>
-          <p:cNvPr id="1224891108" name="Content Placeholder 2"/>
+          <p:cNvPr id="1062635792" name="Content Placeholder 2"/>
           <p:cNvSpPr>
             <a:spLocks noGrp="1"/>
           </p:cNvSpPr>
@@ -6841,7 +6928,7 @@
       </p:sp>
       <p:sp>
         <p:nvSpPr>
-          <p:cNvPr id="2046841799" name="Date Placeholder 14"/>
+          <p:cNvPr id="158755180" name="Date Placeholder 14"/>
           <p:cNvSpPr>
             <a:spLocks noGrp="1"/>
           </p:cNvSpPr>
@@ -6872,7 +6959,7 @@
       </p:sp>
       <p:sp>
         <p:nvSpPr>
-          <p:cNvPr id="492720020" name="Footer Placeholder 15"/>
+          <p:cNvPr id="57558381" name="Footer Placeholder 15"/>
           <p:cNvSpPr>
             <a:spLocks noGrp="1"/>
           </p:cNvSpPr>
@@ -6899,7 +6986,7 @@
       </p:sp>
       <p:sp>
         <p:nvSpPr>
-          <p:cNvPr id="1761962201" name="Slide Number Placeholder 17"/>
+          <p:cNvPr id="1255394827" name="Slide Number Placeholder 17"/>
           <p:cNvSpPr>
             <a:spLocks noGrp="1"/>
           </p:cNvSpPr>
@@ -6955,7 +7042,7 @@
       </p:grpSpPr>
       <p:sp>
         <p:nvSpPr>
-          <p:cNvPr id="854384440" name="Title 1"/>
+          <p:cNvPr id="1475732706" name="Title 1"/>
           <p:cNvSpPr>
             <a:spLocks noGrp="1"/>
           </p:cNvSpPr>
@@ -6994,7 +7081,7 @@
       </p:sp>
       <p:sp>
         <p:nvSpPr>
-          <p:cNvPr id="1227051061" name="Text Placeholder 2"/>
+          <p:cNvPr id="1244649861" name="Text Placeholder 2"/>
           <p:cNvSpPr>
             <a:spLocks noGrp="1"/>
           </p:cNvSpPr>
@@ -7116,7 +7203,7 @@
       </p:sp>
       <p:sp>
         <p:nvSpPr>
-          <p:cNvPr id="1959360844" name="Date Placeholder 6"/>
+          <p:cNvPr id="467479156" name="Date Placeholder 6"/>
           <p:cNvSpPr>
             <a:spLocks noGrp="1"/>
           </p:cNvSpPr>
@@ -7142,7 +7229,7 @@
       </p:sp>
       <p:sp>
         <p:nvSpPr>
-          <p:cNvPr id="846507344" name="Footer Placeholder 7"/>
+          <p:cNvPr id="2097957313" name="Footer Placeholder 7"/>
           <p:cNvSpPr>
             <a:spLocks noGrp="1"/>
           </p:cNvSpPr>
@@ -7164,7 +7251,7 @@
       </p:sp>
       <p:sp>
         <p:nvSpPr>
-          <p:cNvPr id="1732558874" name="Slide Number Placeholder 8"/>
+          <p:cNvPr id="852524835" name="Slide Number Placeholder 8"/>
           <p:cNvSpPr>
             <a:spLocks noGrp="1"/>
           </p:cNvSpPr>
@@ -7215,7 +7302,7 @@
       </p:grpSpPr>
       <p:sp>
         <p:nvSpPr>
-          <p:cNvPr id="2030992036" name="Content Placeholder 2"/>
+          <p:cNvPr id="895090923" name="Content Placeholder 2"/>
           <p:cNvSpPr>
             <a:spLocks noGrp="1"/>
           </p:cNvSpPr>
@@ -7314,7 +7401,7 @@
       </p:sp>
       <p:sp>
         <p:nvSpPr>
-          <p:cNvPr id="1156314780" name="Content Placeholder 3"/>
+          <p:cNvPr id="511983133" name="Content Placeholder 3"/>
           <p:cNvSpPr>
             <a:spLocks noGrp="1"/>
           </p:cNvSpPr>
@@ -7413,7 +7500,7 @@
       </p:sp>
       <p:sp>
         <p:nvSpPr>
-          <p:cNvPr id="507188563" name="Date Placeholder 7"/>
+          <p:cNvPr id="276748792" name="Date Placeholder 7"/>
           <p:cNvSpPr>
             <a:spLocks noGrp="1"/>
           </p:cNvSpPr>
@@ -7439,7 +7526,7 @@
       </p:sp>
       <p:sp>
         <p:nvSpPr>
-          <p:cNvPr id="1599963391" name="Footer Placeholder 8"/>
+          <p:cNvPr id="1503186168" name="Footer Placeholder 8"/>
           <p:cNvSpPr>
             <a:spLocks noGrp="1"/>
           </p:cNvSpPr>
@@ -7461,7 +7548,7 @@
       </p:sp>
       <p:sp>
         <p:nvSpPr>
-          <p:cNvPr id="1200435499" name="Slide Number Placeholder 9"/>
+          <p:cNvPr id="236235408" name="Slide Number Placeholder 9"/>
           <p:cNvSpPr>
             <a:spLocks noGrp="1"/>
           </p:cNvSpPr>
@@ -7487,7 +7574,7 @@
       </p:sp>
       <p:sp>
         <p:nvSpPr>
-          <p:cNvPr id="1765751181" name="Title 10"/>
+          <p:cNvPr id="1587358667" name="Title 10"/>
           <p:cNvSpPr>
             <a:spLocks noGrp="1"/>
           </p:cNvSpPr>
@@ -7538,7 +7625,7 @@
       </p:grpSpPr>
       <p:sp>
         <p:nvSpPr>
-          <p:cNvPr id="123958981" name="Text Placeholder 2"/>
+          <p:cNvPr id="834073352" name="Text Placeholder 2"/>
           <p:cNvSpPr>
             <a:spLocks noGrp="1"/>
           </p:cNvSpPr>
@@ -7606,7 +7693,7 @@
       </p:sp>
       <p:sp>
         <p:nvSpPr>
-          <p:cNvPr id="956929902" name="Content Placeholder 3"/>
+          <p:cNvPr id="828757247" name="Content Placeholder 3"/>
           <p:cNvSpPr>
             <a:spLocks noGrp="1"/>
           </p:cNvSpPr>
@@ -7705,7 +7792,7 @@
       </p:sp>
       <p:sp>
         <p:nvSpPr>
-          <p:cNvPr id="1449012314" name="Text Placeholder 4"/>
+          <p:cNvPr id="649942022" name="Text Placeholder 4"/>
           <p:cNvSpPr>
             <a:spLocks noGrp="1"/>
           </p:cNvSpPr>
@@ -7773,7 +7860,7 @@
       </p:sp>
       <p:sp>
         <p:nvSpPr>
-          <p:cNvPr id="2023625754" name="Content Placeholder 5"/>
+          <p:cNvPr id="891590452" name="Content Placeholder 5"/>
           <p:cNvSpPr>
             <a:spLocks noGrp="1"/>
           </p:cNvSpPr>
@@ -7872,7 +7959,7 @@
       </p:sp>
       <p:sp>
         <p:nvSpPr>
-          <p:cNvPr id="1457851378" name="Date Placeholder 9"/>
+          <p:cNvPr id="1190310374" name="Date Placeholder 9"/>
           <p:cNvSpPr>
             <a:spLocks noGrp="1"/>
           </p:cNvSpPr>
@@ -7898,7 +7985,7 @@
       </p:sp>
       <p:sp>
         <p:nvSpPr>
-          <p:cNvPr id="489966115" name="Footer Placeholder 10"/>
+          <p:cNvPr id="213363553" name="Footer Placeholder 10"/>
           <p:cNvSpPr>
             <a:spLocks noGrp="1"/>
           </p:cNvSpPr>
@@ -7920,7 +8007,7 @@
       </p:sp>
       <p:sp>
         <p:nvSpPr>
-          <p:cNvPr id="2145977266" name="Slide Number Placeholder 11"/>
+          <p:cNvPr id="44636808" name="Slide Number Placeholder 11"/>
           <p:cNvSpPr>
             <a:spLocks noGrp="1"/>
           </p:cNvSpPr>
@@ -7946,7 +8033,7 @@
       </p:sp>
       <p:sp>
         <p:nvSpPr>
-          <p:cNvPr id="1640164282" name="Title 12"/>
+          <p:cNvPr id="1708515526" name="Title 12"/>
           <p:cNvSpPr>
             <a:spLocks noGrp="1"/>
           </p:cNvSpPr>
@@ -7997,7 +8084,7 @@
       </p:grpSpPr>
       <p:sp>
         <p:nvSpPr>
-          <p:cNvPr id="602784195" name="Title 8"/>
+          <p:cNvPr id="1441021990" name="Title 8"/>
           <p:cNvSpPr>
             <a:spLocks noGrp="1"/>
           </p:cNvSpPr>
@@ -8023,7 +8110,7 @@
       </p:sp>
       <p:sp>
         <p:nvSpPr>
-          <p:cNvPr id="64157159" name="Date Placeholder 9"/>
+          <p:cNvPr id="1166820974" name="Date Placeholder 9"/>
           <p:cNvSpPr>
             <a:spLocks noGrp="1"/>
           </p:cNvSpPr>
@@ -8049,7 +8136,7 @@
       </p:sp>
       <p:sp>
         <p:nvSpPr>
-          <p:cNvPr id="633882619" name="Footer Placeholder 10"/>
+          <p:cNvPr id="1463384174" name="Footer Placeholder 10"/>
           <p:cNvSpPr>
             <a:spLocks noGrp="1"/>
           </p:cNvSpPr>
@@ -8071,7 +8158,7 @@
       </p:sp>
       <p:sp>
         <p:nvSpPr>
-          <p:cNvPr id="1320208442" name="Slide Number Placeholder 11"/>
+          <p:cNvPr id="1507233405" name="Slide Number Placeholder 11"/>
           <p:cNvSpPr>
             <a:spLocks noGrp="1"/>
           </p:cNvSpPr>
@@ -8122,7 +8209,7 @@
       </p:grpSpPr>
       <p:sp>
         <p:nvSpPr>
-          <p:cNvPr id="809330420" name="Date Placeholder 18"/>
+          <p:cNvPr id="1410632858" name="Date Placeholder 18"/>
           <p:cNvSpPr>
             <a:spLocks noGrp="1"/>
           </p:cNvSpPr>
@@ -8148,7 +8235,7 @@
       </p:sp>
       <p:sp>
         <p:nvSpPr>
-          <p:cNvPr id="246330805" name="Footer Placeholder 19"/>
+          <p:cNvPr id="1745389066" name="Footer Placeholder 19"/>
           <p:cNvSpPr>
             <a:spLocks noGrp="1"/>
           </p:cNvSpPr>
@@ -8170,7 +8257,7 @@
       </p:sp>
       <p:sp>
         <p:nvSpPr>
-          <p:cNvPr id="2096953999" name="Slide Number Placeholder 20"/>
+          <p:cNvPr id="557686603" name="Slide Number Placeholder 20"/>
           <p:cNvSpPr>
             <a:spLocks noGrp="1"/>
           </p:cNvSpPr>
@@ -8221,7 +8308,7 @@
       </p:grpSpPr>
       <p:sp>
         <p:nvSpPr>
-          <p:cNvPr id="1720322277" name="Content Placeholder 2"/>
+          <p:cNvPr id="1718956437" name="Content Placeholder 2"/>
           <p:cNvSpPr>
             <a:spLocks noGrp="1"/>
           </p:cNvSpPr>
@@ -8322,7 +8409,7 @@
       </p:sp>
       <p:sp>
         <p:nvSpPr>
-          <p:cNvPr id="14888583" name="Text Placeholder 3"/>
+          <p:cNvPr id="1293228806" name="Text Placeholder 3"/>
           <p:cNvSpPr>
             <a:spLocks noGrp="1"/>
           </p:cNvSpPr>
@@ -8398,7 +8485,7 @@
       </p:sp>
       <p:sp>
         <p:nvSpPr>
-          <p:cNvPr id="101452800" name="Date Placeholder 4"/>
+          <p:cNvPr id="841972083" name="Date Placeholder 4"/>
           <p:cNvSpPr>
             <a:spLocks noGrp="1"/>
           </p:cNvSpPr>
@@ -8424,7 +8511,7 @@
       </p:sp>
       <p:sp>
         <p:nvSpPr>
-          <p:cNvPr id="571471760" name="Footer Placeholder 5"/>
+          <p:cNvPr id="1983792325" name="Footer Placeholder 5"/>
           <p:cNvSpPr>
             <a:spLocks noGrp="1"/>
           </p:cNvSpPr>
@@ -8446,7 +8533,7 @@
       </p:sp>
       <p:sp>
         <p:nvSpPr>
-          <p:cNvPr id="1329584795" name="Slide Number Placeholder 6"/>
+          <p:cNvPr id="1226518374" name="Slide Number Placeholder 6"/>
           <p:cNvSpPr>
             <a:spLocks noGrp="1"/>
           </p:cNvSpPr>
@@ -8472,7 +8559,7 @@
       </p:sp>
       <p:sp>
         <p:nvSpPr>
-          <p:cNvPr id="1911085847" name="Title 8"/>
+          <p:cNvPr id="908612544" name="Title 8"/>
           <p:cNvSpPr>
             <a:spLocks noGrp="1"/>
           </p:cNvSpPr>
@@ -8523,7 +8610,7 @@
       </p:grpSpPr>
       <p:sp>
         <p:nvSpPr>
-          <p:cNvPr id="846572537" name="Title 1"/>
+          <p:cNvPr id="1632059715" name="Title 1"/>
           <p:cNvSpPr>
             <a:spLocks noGrp="1"/>
           </p:cNvSpPr>
@@ -8549,7 +8636,7 @@
       </p:sp>
       <p:sp>
         <p:nvSpPr>
-          <p:cNvPr id="1142329826" name="Content Placeholder 2"/>
+          <p:cNvPr id="1984388573" name="Content Placeholder 2"/>
           <p:cNvSpPr>
             <a:spLocks noGrp="1"/>
           </p:cNvSpPr>
@@ -8615,7 +8702,7 @@
       </p:sp>
       <p:sp>
         <p:nvSpPr>
-          <p:cNvPr id="1232691375" name="Date Placeholder 14"/>
+          <p:cNvPr id="1795239472" name="Date Placeholder 14"/>
           <p:cNvSpPr>
             <a:spLocks noGrp="1"/>
           </p:cNvSpPr>
@@ -8646,7 +8733,7 @@
       </p:sp>
       <p:sp>
         <p:nvSpPr>
-          <p:cNvPr id="328512230" name="Footer Placeholder 15"/>
+          <p:cNvPr id="2023312001" name="Footer Placeholder 15"/>
           <p:cNvSpPr>
             <a:spLocks noGrp="1"/>
           </p:cNvSpPr>
@@ -8673,7 +8760,7 @@
       </p:sp>
       <p:sp>
         <p:nvSpPr>
-          <p:cNvPr id="360685321" name="Slide Number Placeholder 17"/>
+          <p:cNvPr id="2093070314" name="Slide Number Placeholder 17"/>
           <p:cNvSpPr>
             <a:spLocks noGrp="1"/>
           </p:cNvSpPr>
@@ -8729,7 +8816,7 @@
       </p:grpSpPr>
       <p:sp>
         <p:nvSpPr>
-          <p:cNvPr id="921641752" name="Title 1"/>
+          <p:cNvPr id="1675390954" name="Title 1"/>
           <p:cNvSpPr>
             <a:spLocks noGrp="1"/>
           </p:cNvSpPr>
@@ -8764,7 +8851,7 @@
       </p:sp>
       <p:sp>
         <p:nvSpPr>
-          <p:cNvPr id="564785795" name="Picture Placeholder 2"/>
+          <p:cNvPr id="498936872" name="Picture Placeholder 2"/>
           <p:cNvSpPr>
             <a:spLocks noGrp="1"/>
           </p:cNvSpPr>
@@ -8832,7 +8919,7 @@
       </p:sp>
       <p:sp>
         <p:nvSpPr>
-          <p:cNvPr id="1113256797" name="Text Placeholder 3"/>
+          <p:cNvPr id="2006916858" name="Text Placeholder 3"/>
           <p:cNvSpPr>
             <a:spLocks noGrp="1"/>
           </p:cNvSpPr>
@@ -8900,7 +8987,7 @@
       </p:sp>
       <p:sp>
         <p:nvSpPr>
-          <p:cNvPr id="783816668" name="Date Placeholder 8"/>
+          <p:cNvPr id="1530527920" name="Date Placeholder 8"/>
           <p:cNvSpPr>
             <a:spLocks noGrp="1"/>
           </p:cNvSpPr>
@@ -8926,7 +9013,7 @@
       </p:sp>
       <p:sp>
         <p:nvSpPr>
-          <p:cNvPr id="1746978802" name="Footer Placeholder 9"/>
+          <p:cNvPr id="90177595" name="Footer Placeholder 9"/>
           <p:cNvSpPr>
             <a:spLocks noGrp="1"/>
           </p:cNvSpPr>
@@ -8948,7 +9035,7 @@
       </p:sp>
       <p:sp>
         <p:nvSpPr>
-          <p:cNvPr id="1989897172" name="Slide Number Placeholder 10"/>
+          <p:cNvPr id="96489463" name="Slide Number Placeholder 10"/>
           <p:cNvSpPr>
             <a:spLocks noGrp="1"/>
           </p:cNvSpPr>
@@ -8999,7 +9086,7 @@
       </p:grpSpPr>
       <p:sp>
         <p:nvSpPr>
-          <p:cNvPr id="378788483" name="Title 1"/>
+          <p:cNvPr id="78038984" name="Title 1"/>
           <p:cNvSpPr>
             <a:spLocks noGrp="1"/>
           </p:cNvSpPr>
@@ -9025,7 +9112,7 @@
       </p:sp>
       <p:sp>
         <p:nvSpPr>
-          <p:cNvPr id="462505655" name="Vertical Text Placeholder 2"/>
+          <p:cNvPr id="92787529" name="Vertical Text Placeholder 2"/>
           <p:cNvSpPr>
             <a:spLocks noGrp="1"/>
           </p:cNvSpPr>
@@ -9091,7 +9178,7 @@
       </p:sp>
       <p:sp>
         <p:nvSpPr>
-          <p:cNvPr id="1800730704" name="Date Placeholder 9"/>
+          <p:cNvPr id="515581330" name="Date Placeholder 9"/>
           <p:cNvSpPr>
             <a:spLocks noGrp="1"/>
           </p:cNvSpPr>
@@ -9117,7 +9204,7 @@
       </p:sp>
       <p:sp>
         <p:nvSpPr>
-          <p:cNvPr id="1298878051" name="Footer Placeholder 10"/>
+          <p:cNvPr id="2049151731" name="Footer Placeholder 10"/>
           <p:cNvSpPr>
             <a:spLocks noGrp="1"/>
           </p:cNvSpPr>
@@ -9139,7 +9226,7 @@
       </p:sp>
       <p:sp>
         <p:nvSpPr>
-          <p:cNvPr id="808110456" name="Slide Number Placeholder 11"/>
+          <p:cNvPr id="1432495824" name="Slide Number Placeholder 11"/>
           <p:cNvSpPr>
             <a:spLocks noGrp="1"/>
           </p:cNvSpPr>
@@ -9190,7 +9277,7 @@
       </p:grpSpPr>
       <p:sp>
         <p:nvSpPr>
-          <p:cNvPr id="1440037819" name="Vertical Title 1"/>
+          <p:cNvPr id="1289669840" name="Vertical Title 1"/>
           <p:cNvSpPr>
             <a:spLocks noGrp="1"/>
           </p:cNvSpPr>
@@ -9225,7 +9312,7 @@
       </p:sp>
       <p:sp>
         <p:nvSpPr>
-          <p:cNvPr id="1963729971" name="Vertical Text Placeholder 2"/>
+          <p:cNvPr id="1823938701" name="Vertical Text Placeholder 2"/>
           <p:cNvSpPr>
             <a:spLocks noGrp="1"/>
           </p:cNvSpPr>
@@ -9296,7 +9383,7 @@
       </p:sp>
       <p:sp>
         <p:nvSpPr>
-          <p:cNvPr id="1968442416" name="Date Placeholder 9"/>
+          <p:cNvPr id="113274798" name="Date Placeholder 9"/>
           <p:cNvSpPr>
             <a:spLocks noGrp="1"/>
           </p:cNvSpPr>
@@ -9322,7 +9409,7 @@
       </p:sp>
       <p:sp>
         <p:nvSpPr>
-          <p:cNvPr id="2089977640" name="Footer Placeholder 10"/>
+          <p:cNvPr id="898655974" name="Footer Placeholder 10"/>
           <p:cNvSpPr>
             <a:spLocks noGrp="1"/>
           </p:cNvSpPr>
@@ -9344,7 +9431,7 @@
       </p:sp>
       <p:sp>
         <p:nvSpPr>
-          <p:cNvPr id="1566210659" name="Slide Number Placeholder 11"/>
+          <p:cNvPr id="912179107" name="Slide Number Placeholder 11"/>
           <p:cNvSpPr>
             <a:spLocks noGrp="1"/>
           </p:cNvSpPr>
@@ -9395,7 +9482,7 @@
       </p:grpSpPr>
       <p:sp>
         <p:nvSpPr>
-          <p:cNvPr id="1073974805" name="Title 1"/>
+          <p:cNvPr id="1717816378" name="Title 1"/>
           <p:cNvSpPr>
             <a:spLocks noGrp="1"/>
           </p:cNvSpPr>
@@ -9434,7 +9521,7 @@
       </p:sp>
       <p:sp>
         <p:nvSpPr>
-          <p:cNvPr id="1810151744" name="Text Placeholder 2"/>
+          <p:cNvPr id="1640698860" name="Text Placeholder 2"/>
           <p:cNvSpPr>
             <a:spLocks noGrp="1"/>
           </p:cNvSpPr>
@@ -9556,7 +9643,7 @@
       </p:sp>
       <p:sp>
         <p:nvSpPr>
-          <p:cNvPr id="2051794412" name="Date Placeholder 6"/>
+          <p:cNvPr id="1062741511" name="Date Placeholder 6"/>
           <p:cNvSpPr>
             <a:spLocks noGrp="1"/>
           </p:cNvSpPr>
@@ -9582,7 +9669,7 @@
       </p:sp>
       <p:sp>
         <p:nvSpPr>
-          <p:cNvPr id="1261118844" name="Footer Placeholder 7"/>
+          <p:cNvPr id="594549021" name="Footer Placeholder 7"/>
           <p:cNvSpPr>
             <a:spLocks noGrp="1"/>
           </p:cNvSpPr>
@@ -9604,7 +9691,7 @@
       </p:sp>
       <p:sp>
         <p:nvSpPr>
-          <p:cNvPr id="1268138659" name="Slide Number Placeholder 8"/>
+          <p:cNvPr id="1784093224" name="Slide Number Placeholder 8"/>
           <p:cNvSpPr>
             <a:spLocks noGrp="1"/>
           </p:cNvSpPr>
@@ -9655,7 +9742,7 @@
       </p:grpSpPr>
       <p:sp>
         <p:nvSpPr>
-          <p:cNvPr id="1170890131" name="Content Placeholder 2"/>
+          <p:cNvPr id="253206207" name="Content Placeholder 2"/>
           <p:cNvSpPr>
             <a:spLocks noGrp="1"/>
           </p:cNvSpPr>
@@ -9754,7 +9841,7 @@
       </p:sp>
       <p:sp>
         <p:nvSpPr>
-          <p:cNvPr id="360157078" name="Content Placeholder 3"/>
+          <p:cNvPr id="1345155669" name="Content Placeholder 3"/>
           <p:cNvSpPr>
             <a:spLocks noGrp="1"/>
           </p:cNvSpPr>
@@ -9853,7 +9940,7 @@
       </p:sp>
       <p:sp>
         <p:nvSpPr>
-          <p:cNvPr id="290076212" name="Date Placeholder 7"/>
+          <p:cNvPr id="482712117" name="Date Placeholder 7"/>
           <p:cNvSpPr>
             <a:spLocks noGrp="1"/>
           </p:cNvSpPr>
@@ -9879,7 +9966,7 @@
       </p:sp>
       <p:sp>
         <p:nvSpPr>
-          <p:cNvPr id="644076247" name="Footer Placeholder 8"/>
+          <p:cNvPr id="755152783" name="Footer Placeholder 8"/>
           <p:cNvSpPr>
             <a:spLocks noGrp="1"/>
           </p:cNvSpPr>
@@ -9901,7 +9988,7 @@
       </p:sp>
       <p:sp>
         <p:nvSpPr>
-          <p:cNvPr id="373509559" name="Slide Number Placeholder 9"/>
+          <p:cNvPr id="893771611" name="Slide Number Placeholder 9"/>
           <p:cNvSpPr>
             <a:spLocks noGrp="1"/>
           </p:cNvSpPr>
@@ -9927,7 +10014,7 @@
       </p:sp>
       <p:sp>
         <p:nvSpPr>
-          <p:cNvPr id="1729905565" name="Title 10"/>
+          <p:cNvPr id="1188182772" name="Title 10"/>
           <p:cNvSpPr>
             <a:spLocks noGrp="1"/>
           </p:cNvSpPr>
@@ -9978,7 +10065,7 @@
       </p:grpSpPr>
       <p:sp>
         <p:nvSpPr>
-          <p:cNvPr id="485214397" name="Text Placeholder 2"/>
+          <p:cNvPr id="1724920113" name="Text Placeholder 2"/>
           <p:cNvSpPr>
             <a:spLocks noGrp="1"/>
           </p:cNvSpPr>
@@ -10046,7 +10133,7 @@
       </p:sp>
       <p:sp>
         <p:nvSpPr>
-          <p:cNvPr id="909517293" name="Content Placeholder 3"/>
+          <p:cNvPr id="362498390" name="Content Placeholder 3"/>
           <p:cNvSpPr>
             <a:spLocks noGrp="1"/>
           </p:cNvSpPr>
@@ -10145,7 +10232,7 @@
       </p:sp>
       <p:sp>
         <p:nvSpPr>
-          <p:cNvPr id="628951962" name="Text Placeholder 4"/>
+          <p:cNvPr id="1631326773" name="Text Placeholder 4"/>
           <p:cNvSpPr>
             <a:spLocks noGrp="1"/>
           </p:cNvSpPr>
@@ -10213,7 +10300,7 @@
       </p:sp>
       <p:sp>
         <p:nvSpPr>
-          <p:cNvPr id="1629499404" name="Content Placeholder 5"/>
+          <p:cNvPr id="1233750664" name="Content Placeholder 5"/>
           <p:cNvSpPr>
             <a:spLocks noGrp="1"/>
           </p:cNvSpPr>
@@ -10312,7 +10399,7 @@
       </p:sp>
       <p:sp>
         <p:nvSpPr>
-          <p:cNvPr id="2080617728" name="Date Placeholder 9"/>
+          <p:cNvPr id="1021364322" name="Date Placeholder 9"/>
           <p:cNvSpPr>
             <a:spLocks noGrp="1"/>
           </p:cNvSpPr>
@@ -10338,7 +10425,7 @@
       </p:sp>
       <p:sp>
         <p:nvSpPr>
-          <p:cNvPr id="1202664015" name="Footer Placeholder 10"/>
+          <p:cNvPr id="1880022042" name="Footer Placeholder 10"/>
           <p:cNvSpPr>
             <a:spLocks noGrp="1"/>
           </p:cNvSpPr>
@@ -10360,7 +10447,7 @@
       </p:sp>
       <p:sp>
         <p:nvSpPr>
-          <p:cNvPr id="1758813057" name="Slide Number Placeholder 11"/>
+          <p:cNvPr id="1025224047" name="Slide Number Placeholder 11"/>
           <p:cNvSpPr>
             <a:spLocks noGrp="1"/>
           </p:cNvSpPr>
@@ -10386,7 +10473,7 @@
       </p:sp>
       <p:sp>
         <p:nvSpPr>
-          <p:cNvPr id="1020491531" name="Title 12"/>
+          <p:cNvPr id="1881109180" name="Title 12"/>
           <p:cNvSpPr>
             <a:spLocks noGrp="1"/>
           </p:cNvSpPr>
@@ -10437,7 +10524,7 @@
       </p:grpSpPr>
       <p:sp>
         <p:nvSpPr>
-          <p:cNvPr id="1236719790" name="Title 8"/>
+          <p:cNvPr id="652177726" name="Title 8"/>
           <p:cNvSpPr>
             <a:spLocks noGrp="1"/>
           </p:cNvSpPr>
@@ -10463,7 +10550,7 @@
       </p:sp>
       <p:sp>
         <p:nvSpPr>
-          <p:cNvPr id="1209746447" name="Date Placeholder 9"/>
+          <p:cNvPr id="1897538519" name="Date Placeholder 9"/>
           <p:cNvSpPr>
             <a:spLocks noGrp="1"/>
           </p:cNvSpPr>
@@ -10489,7 +10576,7 @@
       </p:sp>
       <p:sp>
         <p:nvSpPr>
-          <p:cNvPr id="1582285125" name="Footer Placeholder 10"/>
+          <p:cNvPr id="1763607860" name="Footer Placeholder 10"/>
           <p:cNvSpPr>
             <a:spLocks noGrp="1"/>
           </p:cNvSpPr>
@@ -10511,7 +10598,7 @@
       </p:sp>
       <p:sp>
         <p:nvSpPr>
-          <p:cNvPr id="558490137" name="Slide Number Placeholder 11"/>
+          <p:cNvPr id="1456194593" name="Slide Number Placeholder 11"/>
           <p:cNvSpPr>
             <a:spLocks noGrp="1"/>
           </p:cNvSpPr>
@@ -10562,7 +10649,7 @@
       </p:grpSpPr>
       <p:sp>
         <p:nvSpPr>
-          <p:cNvPr id="1336555140" name="Date Placeholder 18"/>
+          <p:cNvPr id="1003248193" name="Date Placeholder 18"/>
           <p:cNvSpPr>
             <a:spLocks noGrp="1"/>
           </p:cNvSpPr>
@@ -10588,7 +10675,7 @@
       </p:sp>
       <p:sp>
         <p:nvSpPr>
-          <p:cNvPr id="1068565943" name="Footer Placeholder 19"/>
+          <p:cNvPr id="242102124" name="Footer Placeholder 19"/>
           <p:cNvSpPr>
             <a:spLocks noGrp="1"/>
           </p:cNvSpPr>
@@ -10610,7 +10697,7 @@
       </p:sp>
       <p:sp>
         <p:nvSpPr>
-          <p:cNvPr id="767386021" name="Slide Number Placeholder 20"/>
+          <p:cNvPr id="601155743" name="Slide Number Placeholder 20"/>
           <p:cNvSpPr>
             <a:spLocks noGrp="1"/>
           </p:cNvSpPr>
@@ -10661,7 +10748,7 @@
       </p:grpSpPr>
       <p:sp>
         <p:nvSpPr>
-          <p:cNvPr id="680017903" name="Content Placeholder 2"/>
+          <p:cNvPr id="630316804" name="Content Placeholder 2"/>
           <p:cNvSpPr>
             <a:spLocks noGrp="1"/>
           </p:cNvSpPr>
@@ -10762,7 +10849,7 @@
       </p:sp>
       <p:sp>
         <p:nvSpPr>
-          <p:cNvPr id="828191082" name="Text Placeholder 3"/>
+          <p:cNvPr id="1196599571" name="Text Placeholder 3"/>
           <p:cNvSpPr>
             <a:spLocks noGrp="1"/>
           </p:cNvSpPr>
@@ -10838,7 +10925,7 @@
       </p:sp>
       <p:sp>
         <p:nvSpPr>
-          <p:cNvPr id="1065013993" name="Date Placeholder 4"/>
+          <p:cNvPr id="687580848" name="Date Placeholder 4"/>
           <p:cNvSpPr>
             <a:spLocks noGrp="1"/>
           </p:cNvSpPr>
@@ -10864,7 +10951,7 @@
       </p:sp>
       <p:sp>
         <p:nvSpPr>
-          <p:cNvPr id="379180030" name="Footer Placeholder 5"/>
+          <p:cNvPr id="245640811" name="Footer Placeholder 5"/>
           <p:cNvSpPr>
             <a:spLocks noGrp="1"/>
           </p:cNvSpPr>
@@ -10886,7 +10973,7 @@
       </p:sp>
       <p:sp>
         <p:nvSpPr>
-          <p:cNvPr id="1141383957" name="Slide Number Placeholder 6"/>
+          <p:cNvPr id="299499012" name="Slide Number Placeholder 6"/>
           <p:cNvSpPr>
             <a:spLocks noGrp="1"/>
           </p:cNvSpPr>
@@ -10912,7 +10999,7 @@
       </p:sp>
       <p:sp>
         <p:nvSpPr>
-          <p:cNvPr id="520141225" name="Title 8"/>
+          <p:cNvPr id="125378955" name="Title 8"/>
           <p:cNvSpPr>
             <a:spLocks noGrp="1"/>
           </p:cNvSpPr>
@@ -10963,7 +11050,7 @@
       </p:grpSpPr>
       <p:sp>
         <p:nvSpPr>
-          <p:cNvPr id="514382176" name="Title 1"/>
+          <p:cNvPr id="551575662" name="Title 1"/>
           <p:cNvSpPr>
             <a:spLocks noGrp="1"/>
           </p:cNvSpPr>
@@ -10998,7 +11085,7 @@
       </p:sp>
       <p:sp>
         <p:nvSpPr>
-          <p:cNvPr id="85202209" name="Picture Placeholder 2"/>
+          <p:cNvPr id="100001565" name="Picture Placeholder 2"/>
           <p:cNvSpPr>
             <a:spLocks noGrp="1"/>
           </p:cNvSpPr>
@@ -11066,7 +11153,7 @@
       </p:sp>
       <p:sp>
         <p:nvSpPr>
-          <p:cNvPr id="941180020" name="Text Placeholder 3"/>
+          <p:cNvPr id="262868375" name="Text Placeholder 3"/>
           <p:cNvSpPr>
             <a:spLocks noGrp="1"/>
           </p:cNvSpPr>
@@ -11134,7 +11221,7 @@
       </p:sp>
       <p:sp>
         <p:nvSpPr>
-          <p:cNvPr id="532714189" name="Date Placeholder 8"/>
+          <p:cNvPr id="1294512425" name="Date Placeholder 8"/>
           <p:cNvSpPr>
             <a:spLocks noGrp="1"/>
           </p:cNvSpPr>
@@ -11160,7 +11247,7 @@
       </p:sp>
       <p:sp>
         <p:nvSpPr>
-          <p:cNvPr id="1844962098" name="Footer Placeholder 9"/>
+          <p:cNvPr id="181829872" name="Footer Placeholder 9"/>
           <p:cNvSpPr>
             <a:spLocks noGrp="1"/>
           </p:cNvSpPr>
@@ -11182,7 +11269,7 @@
       </p:sp>
       <p:sp>
         <p:nvSpPr>
-          <p:cNvPr id="676101528" name="Slide Number Placeholder 10"/>
+          <p:cNvPr id="1040797999" name="Slide Number Placeholder 10"/>
           <p:cNvSpPr>
             <a:spLocks noGrp="1"/>
           </p:cNvSpPr>
@@ -11238,7 +11325,7 @@
       </p:grpSpPr>
       <p:sp>
         <p:nvSpPr>
-          <p:cNvPr id="1002095677" name="Rectangle 245"/>
+          <p:cNvPr id="1026726831" name="Rectangle 245"/>
           <p:cNvSpPr/>
           <p:nvPr userDrawn="1"/>
         </p:nvSpPr>
@@ -11260,7 +11347,7 @@
       </p:sp>
       <p:sp>
         <p:nvSpPr>
-          <p:cNvPr id="492551843" name="Rectangle 350"/>
+          <p:cNvPr id="1693614171" name="Rectangle 350"/>
           <p:cNvSpPr/>
           <p:nvPr userDrawn="1"/>
         </p:nvSpPr>
@@ -11282,7 +11369,7 @@
       </p:sp>
       <p:grpSp>
         <p:nvGrpSpPr>
-          <p:cNvPr id="87980060" name="Group 6"/>
+          <p:cNvPr id="1342307790" name="Group 6"/>
           <p:cNvGrpSpPr/>
           <p:nvPr userDrawn="1"/>
         </p:nvGrpSpPr>
@@ -14247,7 +14334,7 @@
       </p:grpSp>
       <p:sp>
         <p:nvSpPr>
-          <p:cNvPr id="1528536093" name="Rectangle 482"/>
+          <p:cNvPr id="1012359155" name="Rectangle 482"/>
           <p:cNvSpPr/>
           <p:nvPr userDrawn="1"/>
         </p:nvSpPr>
@@ -14269,7 +14356,7 @@
       </p:sp>
       <p:sp>
         <p:nvSpPr>
-          <p:cNvPr id="663267308" name="Rectangle 487"/>
+          <p:cNvPr id="1493476601" name="Rectangle 487"/>
           <p:cNvSpPr/>
           <p:nvPr userDrawn="1"/>
         </p:nvSpPr>
@@ -14295,7 +14382,7 @@
       </p:sp>
       <p:sp>
         <p:nvSpPr>
-          <p:cNvPr id="590589482" name="Rectangle 488"/>
+          <p:cNvPr id="647425885" name="Rectangle 488"/>
           <p:cNvSpPr/>
           <p:nvPr userDrawn="1"/>
         </p:nvSpPr>
@@ -14321,7 +14408,7 @@
       </p:sp>
       <p:sp>
         <p:nvSpPr>
-          <p:cNvPr id="1595924671" name="Rectangle 489"/>
+          <p:cNvPr id="700550035" name="Rectangle 489"/>
           <p:cNvSpPr/>
           <p:nvPr userDrawn="1"/>
         </p:nvSpPr>
@@ -14347,7 +14434,7 @@
       </p:sp>
       <p:sp>
         <p:nvSpPr>
-          <p:cNvPr id="762795184" name="Rectangle 471"/>
+          <p:cNvPr id="1643470049" name="Rectangle 471"/>
           <p:cNvSpPr/>
           <p:nvPr userDrawn="1"/>
         </p:nvSpPr>
@@ -14369,7 +14456,7 @@
       </p:sp>
       <p:sp>
         <p:nvSpPr>
-          <p:cNvPr id="1407800636" name="Rectangle 476"/>
+          <p:cNvPr id="1823033024" name="Rectangle 476"/>
           <p:cNvSpPr/>
           <p:nvPr userDrawn="1"/>
         </p:nvSpPr>
@@ -14395,7 +14482,7 @@
       </p:sp>
       <p:sp>
         <p:nvSpPr>
-          <p:cNvPr id="282029708" name="Rectangle 477"/>
+          <p:cNvPr id="2050231818" name="Rectangle 477"/>
           <p:cNvSpPr/>
           <p:nvPr userDrawn="1"/>
         </p:nvSpPr>
@@ -14421,7 +14508,7 @@
       </p:sp>
       <p:sp>
         <p:nvSpPr>
-          <p:cNvPr id="1241724385" name="Rectangle 478"/>
+          <p:cNvPr id="1171839091" name="Rectangle 478"/>
           <p:cNvSpPr/>
           <p:nvPr userDrawn="1"/>
         </p:nvSpPr>
@@ -14447,7 +14534,7 @@
       </p:sp>
       <p:sp>
         <p:nvSpPr>
-          <p:cNvPr id="468828590" name="Rectangle 460"/>
+          <p:cNvPr id="1627634095" name="Rectangle 460"/>
           <p:cNvSpPr/>
           <p:nvPr userDrawn="1"/>
         </p:nvSpPr>
@@ -14469,7 +14556,7 @@
       </p:sp>
       <p:sp>
         <p:nvSpPr>
-          <p:cNvPr id="361626069" name="Rectangle 465"/>
+          <p:cNvPr id="738943764" name="Rectangle 465"/>
           <p:cNvSpPr/>
           <p:nvPr userDrawn="1"/>
         </p:nvSpPr>
@@ -14494,7 +14581,7 @@
       </p:sp>
       <p:sp>
         <p:nvSpPr>
-          <p:cNvPr id="2081854157" name="Rectangle 466"/>
+          <p:cNvPr id="604521763" name="Rectangle 466"/>
           <p:cNvSpPr/>
           <p:nvPr userDrawn="1"/>
         </p:nvSpPr>
@@ -14520,7 +14607,7 @@
       </p:sp>
       <p:sp>
         <p:nvSpPr>
-          <p:cNvPr id="595439669" name="Rectangle 467"/>
+          <p:cNvPr id="1936368438" name="Rectangle 467"/>
           <p:cNvSpPr/>
           <p:nvPr userDrawn="1"/>
         </p:nvSpPr>
@@ -14546,7 +14633,7 @@
       </p:sp>
       <p:sp>
         <p:nvSpPr>
-          <p:cNvPr id="114538875" name="Rectangle 449"/>
+          <p:cNvPr id="1900067024" name="Rectangle 449"/>
           <p:cNvSpPr/>
           <p:nvPr userDrawn="1"/>
         </p:nvSpPr>
@@ -14568,7 +14655,7 @@
       </p:sp>
       <p:sp>
         <p:nvSpPr>
-          <p:cNvPr id="732998492" name="Rectangle 454"/>
+          <p:cNvPr id="333877636" name="Rectangle 454"/>
           <p:cNvSpPr/>
           <p:nvPr userDrawn="1"/>
         </p:nvSpPr>
@@ -14594,7 +14681,7 @@
       </p:sp>
       <p:sp>
         <p:nvSpPr>
-          <p:cNvPr id="1716360694" name="Rectangle 455"/>
+          <p:cNvPr id="831430447" name="Rectangle 455"/>
           <p:cNvSpPr/>
           <p:nvPr userDrawn="1"/>
         </p:nvSpPr>
@@ -14620,7 +14707,7 @@
       </p:sp>
       <p:sp>
         <p:nvSpPr>
-          <p:cNvPr id="1358553527" name="Rectangle 456"/>
+          <p:cNvPr id="1445391627" name="Rectangle 456"/>
           <p:cNvSpPr/>
           <p:nvPr userDrawn="1"/>
         </p:nvSpPr>
@@ -14646,7 +14733,7 @@
       </p:sp>
       <p:sp>
         <p:nvSpPr>
-          <p:cNvPr id="684869961" name="Rectangle 438"/>
+          <p:cNvPr id="1158225251" name="Rectangle 438"/>
           <p:cNvSpPr/>
           <p:nvPr userDrawn="1"/>
         </p:nvSpPr>
@@ -14668,7 +14755,7 @@
       </p:sp>
       <p:sp>
         <p:nvSpPr>
-          <p:cNvPr id="1674506742" name="Rectangle 443"/>
+          <p:cNvPr id="149019190" name="Rectangle 443"/>
           <p:cNvSpPr/>
           <p:nvPr userDrawn="1"/>
         </p:nvSpPr>
@@ -14694,7 +14781,7 @@
       </p:sp>
       <p:sp>
         <p:nvSpPr>
-          <p:cNvPr id="1861567255" name="Rectangle 444"/>
+          <p:cNvPr id="1571921148" name="Rectangle 444"/>
           <p:cNvSpPr/>
           <p:nvPr userDrawn="1"/>
         </p:nvSpPr>
@@ -14720,7 +14807,7 @@
       </p:sp>
       <p:sp>
         <p:nvSpPr>
-          <p:cNvPr id="811601631" name="Rectangle 445"/>
+          <p:cNvPr id="2119908969" name="Rectangle 445"/>
           <p:cNvSpPr/>
           <p:nvPr userDrawn="1"/>
         </p:nvSpPr>
@@ -14746,7 +14833,7 @@
       </p:sp>
       <p:sp>
         <p:nvSpPr>
-          <p:cNvPr id="1725051770" name="Rectangle 422"/>
+          <p:cNvPr id="589794216" name="Rectangle 422"/>
           <p:cNvSpPr/>
           <p:nvPr userDrawn="1"/>
         </p:nvSpPr>
@@ -14768,7 +14855,7 @@
       </p:sp>
       <p:sp>
         <p:nvSpPr>
-          <p:cNvPr id="875978804" name="Rectangle 427"/>
+          <p:cNvPr id="643148884" name="Rectangle 427"/>
           <p:cNvSpPr/>
           <p:nvPr userDrawn="1"/>
         </p:nvSpPr>
@@ -14794,7 +14881,7 @@
       </p:sp>
       <p:sp>
         <p:nvSpPr>
-          <p:cNvPr id="1041789539" name="Rectangle 428"/>
+          <p:cNvPr id="246812875" name="Rectangle 428"/>
           <p:cNvSpPr/>
           <p:nvPr userDrawn="1"/>
         </p:nvSpPr>
@@ -14820,7 +14907,7 @@
       </p:sp>
       <p:sp>
         <p:nvSpPr>
-          <p:cNvPr id="1111155652" name="Rectangle 429"/>
+          <p:cNvPr id="1317536560" name="Rectangle 429"/>
           <p:cNvSpPr/>
           <p:nvPr userDrawn="1"/>
         </p:nvSpPr>
@@ -14846,7 +14933,7 @@
       </p:sp>
       <p:sp>
         <p:nvSpPr>
-          <p:cNvPr id="1756475669" name="Rectangle 411"/>
+          <p:cNvPr id="1745412698" name="Rectangle 411"/>
           <p:cNvSpPr/>
           <p:nvPr userDrawn="1"/>
         </p:nvSpPr>
@@ -14868,7 +14955,7 @@
       </p:sp>
       <p:sp>
         <p:nvSpPr>
-          <p:cNvPr id="1746371594" name="Rectangle 416"/>
+          <p:cNvPr id="1557979887" name="Rectangle 416"/>
           <p:cNvSpPr/>
           <p:nvPr userDrawn="1"/>
         </p:nvSpPr>
@@ -14894,7 +14981,7 @@
       </p:sp>
       <p:sp>
         <p:nvSpPr>
-          <p:cNvPr id="1422687309" name="Rectangle 417"/>
+          <p:cNvPr id="1400042788" name="Rectangle 417"/>
           <p:cNvSpPr/>
           <p:nvPr userDrawn="1"/>
         </p:nvSpPr>
@@ -14920,7 +15007,7 @@
       </p:sp>
       <p:sp>
         <p:nvSpPr>
-          <p:cNvPr id="1419970216" name="Rectangle 418"/>
+          <p:cNvPr id="1278831071" name="Rectangle 418"/>
           <p:cNvSpPr/>
           <p:nvPr userDrawn="1"/>
         </p:nvSpPr>
@@ -14946,7 +15033,7 @@
       </p:sp>
       <p:sp>
         <p:nvSpPr>
-          <p:cNvPr id="2086136142" name="Rectangle 400"/>
+          <p:cNvPr id="467111937" name="Rectangle 400"/>
           <p:cNvSpPr/>
           <p:nvPr userDrawn="1"/>
         </p:nvSpPr>
@@ -14968,7 +15055,7 @@
       </p:sp>
       <p:sp>
         <p:nvSpPr>
-          <p:cNvPr id="973554625" name="Rectangle 405"/>
+          <p:cNvPr id="431175316" name="Rectangle 405"/>
           <p:cNvSpPr/>
           <p:nvPr userDrawn="1"/>
         </p:nvSpPr>
@@ -14993,7 +15080,7 @@
       </p:sp>
       <p:sp>
         <p:nvSpPr>
-          <p:cNvPr id="1413981699" name="Rectangle 406"/>
+          <p:cNvPr id="1868277770" name="Rectangle 406"/>
           <p:cNvSpPr/>
           <p:nvPr userDrawn="1"/>
         </p:nvSpPr>
@@ -15019,7 +15106,7 @@
       </p:sp>
       <p:sp>
         <p:nvSpPr>
-          <p:cNvPr id="1853866002" name="Rectangle 407"/>
+          <p:cNvPr id="1761398542" name="Rectangle 407"/>
           <p:cNvSpPr/>
           <p:nvPr userDrawn="1"/>
         </p:nvSpPr>
@@ -15045,7 +15132,7 @@
       </p:sp>
       <p:sp>
         <p:nvSpPr>
-          <p:cNvPr id="1032029419" name="Rectangle 389"/>
+          <p:cNvPr id="220891857" name="Rectangle 389"/>
           <p:cNvSpPr/>
           <p:nvPr userDrawn="1"/>
         </p:nvSpPr>
@@ -15067,7 +15154,7 @@
       </p:sp>
       <p:sp>
         <p:nvSpPr>
-          <p:cNvPr id="1444363520" name="Rectangle 394"/>
+          <p:cNvPr id="159068238" name="Rectangle 394"/>
           <p:cNvSpPr/>
           <p:nvPr userDrawn="1"/>
         </p:nvSpPr>
@@ -15093,7 +15180,7 @@
       </p:sp>
       <p:sp>
         <p:nvSpPr>
-          <p:cNvPr id="711387877" name="Rectangle 395"/>
+          <p:cNvPr id="369382112" name="Rectangle 395"/>
           <p:cNvSpPr/>
           <p:nvPr userDrawn="1"/>
         </p:nvSpPr>
@@ -15119,7 +15206,7 @@
       </p:sp>
       <p:sp>
         <p:nvSpPr>
-          <p:cNvPr id="1199676205" name="Rectangle 396"/>
+          <p:cNvPr id="929849844" name="Rectangle 396"/>
           <p:cNvSpPr/>
           <p:nvPr userDrawn="1"/>
         </p:nvSpPr>
@@ -15145,7 +15232,7 @@
       </p:sp>
       <p:sp>
         <p:nvSpPr>
-          <p:cNvPr id="268048029" name="Rectangle 378"/>
+          <p:cNvPr id="1076421737" name="Rectangle 378"/>
           <p:cNvSpPr/>
           <p:nvPr userDrawn="1"/>
         </p:nvSpPr>
@@ -15167,7 +15254,7 @@
       </p:sp>
       <p:sp>
         <p:nvSpPr>
-          <p:cNvPr id="320237084" name="Rectangle 383"/>
+          <p:cNvPr id="690863441" name="Rectangle 383"/>
           <p:cNvSpPr/>
           <p:nvPr userDrawn="1"/>
         </p:nvSpPr>
@@ -15193,7 +15280,7 @@
       </p:sp>
       <p:sp>
         <p:nvSpPr>
-          <p:cNvPr id="290018929" name="Rectangle 384"/>
+          <p:cNvPr id="411362954" name="Rectangle 384"/>
           <p:cNvSpPr/>
           <p:nvPr userDrawn="1"/>
         </p:nvSpPr>
@@ -15219,7 +15306,7 @@
       </p:sp>
       <p:sp>
         <p:nvSpPr>
-          <p:cNvPr id="269783671" name="Rectangle 385"/>
+          <p:cNvPr id="671704531" name="Rectangle 385"/>
           <p:cNvSpPr/>
           <p:nvPr userDrawn="1"/>
         </p:nvSpPr>
@@ -15245,7 +15332,7 @@
       </p:sp>
       <p:sp>
         <p:nvSpPr>
-          <p:cNvPr id="126769123" name="Rectangle 365"/>
+          <p:cNvPr id="1528394803" name="Rectangle 365"/>
           <p:cNvSpPr/>
           <p:nvPr userDrawn="1"/>
         </p:nvSpPr>
@@ -15267,7 +15354,7 @@
       </p:sp>
       <p:sp>
         <p:nvSpPr>
-          <p:cNvPr id="1238120322" name="Rectangle 369"/>
+          <p:cNvPr id="476980743" name="Rectangle 369"/>
           <p:cNvSpPr/>
           <p:nvPr userDrawn="1"/>
         </p:nvSpPr>
@@ -15293,7 +15380,7 @@
       </p:sp>
       <p:sp>
         <p:nvSpPr>
-          <p:cNvPr id="793124531" name="Rectangle 370"/>
+          <p:cNvPr id="1676124051" name="Rectangle 370"/>
           <p:cNvSpPr/>
           <p:nvPr userDrawn="1"/>
         </p:nvSpPr>
@@ -15319,7 +15406,7 @@
       </p:sp>
       <p:sp>
         <p:nvSpPr>
-          <p:cNvPr id="1702226565" name="Text Placeholder 2"/>
+          <p:cNvPr id="990586346" name="Text Placeholder 2"/>
           <p:cNvSpPr>
             <a:spLocks noGrp="1"/>
           </p:cNvSpPr>
@@ -15395,7 +15482,7 @@
       </p:sp>
       <p:sp>
         <p:nvSpPr>
-          <p:cNvPr id="1246410387" name="Title 1"/>
+          <p:cNvPr id="745232939" name="Title 1"/>
           <p:cNvSpPr>
             <a:spLocks noGrp="1"/>
           </p:cNvSpPr>
@@ -15436,7 +15523,7 @@
       </p:sp>
       <p:sp>
         <p:nvSpPr>
-          <p:cNvPr id="2011748172" name="Slide Number Placeholder 5"/>
+          <p:cNvPr id="2028643730" name="Slide Number Placeholder 5"/>
           <p:cNvSpPr>
             <a:spLocks noGrp="1"/>
           </p:cNvSpPr>
@@ -15477,7 +15564,7 @@
       </p:sp>
       <p:sp>
         <p:nvSpPr>
-          <p:cNvPr id="1454939760" name="Date Placeholder 3"/>
+          <p:cNvPr id="1865716944" name="Date Placeholder 3"/>
           <p:cNvSpPr>
             <a:spLocks noGrp="1"/>
           </p:cNvSpPr>
@@ -15521,7 +15608,7 @@
       </p:sp>
       <p:sp>
         <p:nvSpPr>
-          <p:cNvPr id="1180087909" name="Footer Placeholder 4"/>
+          <p:cNvPr id="327208170" name="Footer Placeholder 4"/>
           <p:cNvSpPr>
             <a:spLocks noGrp="1"/>
           </p:cNvSpPr>
@@ -15575,6 +15662,7 @@
     <p:sldLayoutId id="2147483658" r:id="rId10"/>
     <p:sldLayoutId id="2147483659" r:id="rId11"/>
   </p:sldLayoutIdLst>
+  <p:hf dt="0" ftr="0" hdr="0" sldNum="1"/>
   <p:txStyles>
     <p:titleStyle>
       <a:lvl1pPr algn="ctr" defTabSz="914400">
@@ -15864,7 +15952,7 @@
       </p:grpSpPr>
       <p:sp>
         <p:nvSpPr>
-          <p:cNvPr id="254652721" name="Rectangle 245"/>
+          <p:cNvPr id="1779283718" name="Rectangle 245"/>
           <p:cNvSpPr/>
           <p:nvPr userDrawn="1"/>
         </p:nvSpPr>
@@ -15886,7 +15974,7 @@
       </p:sp>
       <p:sp>
         <p:nvSpPr>
-          <p:cNvPr id="634393086" name="Rectangle 350"/>
+          <p:cNvPr id="787604481" name="Rectangle 350"/>
           <p:cNvSpPr/>
           <p:nvPr userDrawn="1"/>
         </p:nvSpPr>
@@ -15908,7 +15996,7 @@
       </p:sp>
       <p:grpSp>
         <p:nvGrpSpPr>
-          <p:cNvPr id="577944329" name="Group 6"/>
+          <p:cNvPr id="1612650541" name="Group 6"/>
           <p:cNvGrpSpPr/>
           <p:nvPr userDrawn="1"/>
         </p:nvGrpSpPr>
@@ -18873,7 +18961,7 @@
       </p:grpSp>
       <p:sp>
         <p:nvSpPr>
-          <p:cNvPr id="150989445" name="Rectangle 482"/>
+          <p:cNvPr id="1476011036" name="Rectangle 482"/>
           <p:cNvSpPr/>
           <p:nvPr userDrawn="1"/>
         </p:nvSpPr>
@@ -18895,7 +18983,7 @@
       </p:sp>
       <p:sp>
         <p:nvSpPr>
-          <p:cNvPr id="1166751726" name="Rectangle 487"/>
+          <p:cNvPr id="172562439" name="Rectangle 487"/>
           <p:cNvSpPr/>
           <p:nvPr userDrawn="1"/>
         </p:nvSpPr>
@@ -18921,7 +19009,7 @@
       </p:sp>
       <p:sp>
         <p:nvSpPr>
-          <p:cNvPr id="826611979" name="Rectangle 488"/>
+          <p:cNvPr id="38483878" name="Rectangle 488"/>
           <p:cNvSpPr/>
           <p:nvPr userDrawn="1"/>
         </p:nvSpPr>
@@ -18947,7 +19035,7 @@
       </p:sp>
       <p:sp>
         <p:nvSpPr>
-          <p:cNvPr id="2072621526" name="Rectangle 489"/>
+          <p:cNvPr id="419632922" name="Rectangle 489"/>
           <p:cNvSpPr/>
           <p:nvPr userDrawn="1"/>
         </p:nvSpPr>
@@ -18973,7 +19061,7 @@
       </p:sp>
       <p:sp>
         <p:nvSpPr>
-          <p:cNvPr id="200432524" name="Rectangle 471"/>
+          <p:cNvPr id="1723356900" name="Rectangle 471"/>
           <p:cNvSpPr/>
           <p:nvPr userDrawn="1"/>
         </p:nvSpPr>
@@ -18995,7 +19083,7 @@
       </p:sp>
       <p:sp>
         <p:nvSpPr>
-          <p:cNvPr id="803581013" name="Rectangle 476"/>
+          <p:cNvPr id="1172627340" name="Rectangle 476"/>
           <p:cNvSpPr/>
           <p:nvPr userDrawn="1"/>
         </p:nvSpPr>
@@ -19021,7 +19109,7 @@
       </p:sp>
       <p:sp>
         <p:nvSpPr>
-          <p:cNvPr id="1560849008" name="Rectangle 477"/>
+          <p:cNvPr id="972961477" name="Rectangle 477"/>
           <p:cNvSpPr/>
           <p:nvPr userDrawn="1"/>
         </p:nvSpPr>
@@ -19047,7 +19135,7 @@
       </p:sp>
       <p:sp>
         <p:nvSpPr>
-          <p:cNvPr id="1950718320" name="Rectangle 478"/>
+          <p:cNvPr id="908129081" name="Rectangle 478"/>
           <p:cNvSpPr/>
           <p:nvPr userDrawn="1"/>
         </p:nvSpPr>
@@ -19073,7 +19161,7 @@
       </p:sp>
       <p:sp>
         <p:nvSpPr>
-          <p:cNvPr id="910270008" name="Rectangle 460"/>
+          <p:cNvPr id="1872121887" name="Rectangle 460"/>
           <p:cNvSpPr/>
           <p:nvPr userDrawn="1"/>
         </p:nvSpPr>
@@ -19095,7 +19183,7 @@
       </p:sp>
       <p:sp>
         <p:nvSpPr>
-          <p:cNvPr id="59272831" name="Rectangle 465"/>
+          <p:cNvPr id="1710249288" name="Rectangle 465"/>
           <p:cNvSpPr/>
           <p:nvPr userDrawn="1"/>
         </p:nvSpPr>
@@ -19120,7 +19208,7 @@
       </p:sp>
       <p:sp>
         <p:nvSpPr>
-          <p:cNvPr id="404820294" name="Rectangle 466"/>
+          <p:cNvPr id="1574365885" name="Rectangle 466"/>
           <p:cNvSpPr/>
           <p:nvPr userDrawn="1"/>
         </p:nvSpPr>
@@ -19146,7 +19234,7 @@
       </p:sp>
       <p:sp>
         <p:nvSpPr>
-          <p:cNvPr id="225532707" name="Rectangle 467"/>
+          <p:cNvPr id="683373551" name="Rectangle 467"/>
           <p:cNvSpPr/>
           <p:nvPr userDrawn="1"/>
         </p:nvSpPr>
@@ -19172,7 +19260,7 @@
       </p:sp>
       <p:sp>
         <p:nvSpPr>
-          <p:cNvPr id="2086591569" name="Rectangle 449"/>
+          <p:cNvPr id="1650769262" name="Rectangle 449"/>
           <p:cNvSpPr/>
           <p:nvPr userDrawn="1"/>
         </p:nvSpPr>
@@ -19194,7 +19282,7 @@
       </p:sp>
       <p:sp>
         <p:nvSpPr>
-          <p:cNvPr id="49419533" name="Rectangle 454"/>
+          <p:cNvPr id="272286365" name="Rectangle 454"/>
           <p:cNvSpPr/>
           <p:nvPr userDrawn="1"/>
         </p:nvSpPr>
@@ -19220,7 +19308,7 @@
       </p:sp>
       <p:sp>
         <p:nvSpPr>
-          <p:cNvPr id="206298771" name="Rectangle 455"/>
+          <p:cNvPr id="1733489986" name="Rectangle 455"/>
           <p:cNvSpPr/>
           <p:nvPr userDrawn="1"/>
         </p:nvSpPr>
@@ -19246,7 +19334,7 @@
       </p:sp>
       <p:sp>
         <p:nvSpPr>
-          <p:cNvPr id="541283873" name="Rectangle 456"/>
+          <p:cNvPr id="331331297" name="Rectangle 456"/>
           <p:cNvSpPr/>
           <p:nvPr userDrawn="1"/>
         </p:nvSpPr>
@@ -19272,7 +19360,7 @@
       </p:sp>
       <p:sp>
         <p:nvSpPr>
-          <p:cNvPr id="2009696216" name="Rectangle 438"/>
+          <p:cNvPr id="163697353" name="Rectangle 438"/>
           <p:cNvSpPr/>
           <p:nvPr userDrawn="1"/>
         </p:nvSpPr>
@@ -19294,7 +19382,7 @@
       </p:sp>
       <p:sp>
         <p:nvSpPr>
-          <p:cNvPr id="1692263213" name="Rectangle 443"/>
+          <p:cNvPr id="1505577059" name="Rectangle 443"/>
           <p:cNvSpPr/>
           <p:nvPr userDrawn="1"/>
         </p:nvSpPr>
@@ -19320,7 +19408,7 @@
       </p:sp>
       <p:sp>
         <p:nvSpPr>
-          <p:cNvPr id="203150221" name="Rectangle 444"/>
+          <p:cNvPr id="1471929294" name="Rectangle 444"/>
           <p:cNvSpPr/>
           <p:nvPr userDrawn="1"/>
         </p:nvSpPr>
@@ -19346,7 +19434,7 @@
       </p:sp>
       <p:sp>
         <p:nvSpPr>
-          <p:cNvPr id="1076796557" name="Rectangle 445"/>
+          <p:cNvPr id="1957471531" name="Rectangle 445"/>
           <p:cNvSpPr/>
           <p:nvPr userDrawn="1"/>
         </p:nvSpPr>
@@ -19372,7 +19460,7 @@
       </p:sp>
       <p:sp>
         <p:nvSpPr>
-          <p:cNvPr id="1175709564" name="Rectangle 422"/>
+          <p:cNvPr id="2081307105" name="Rectangle 422"/>
           <p:cNvSpPr/>
           <p:nvPr userDrawn="1"/>
         </p:nvSpPr>
@@ -19394,7 +19482,7 @@
       </p:sp>
       <p:sp>
         <p:nvSpPr>
-          <p:cNvPr id="1047066368" name="Rectangle 427"/>
+          <p:cNvPr id="954228857" name="Rectangle 427"/>
           <p:cNvSpPr/>
           <p:nvPr userDrawn="1"/>
         </p:nvSpPr>
@@ -19420,7 +19508,7 @@
       </p:sp>
       <p:sp>
         <p:nvSpPr>
-          <p:cNvPr id="1169517741" name="Rectangle 428"/>
+          <p:cNvPr id="110796865" name="Rectangle 428"/>
           <p:cNvSpPr/>
           <p:nvPr userDrawn="1"/>
         </p:nvSpPr>
@@ -19446,7 +19534,7 @@
       </p:sp>
       <p:sp>
         <p:nvSpPr>
-          <p:cNvPr id="925121420" name="Rectangle 429"/>
+          <p:cNvPr id="151290721" name="Rectangle 429"/>
           <p:cNvSpPr/>
           <p:nvPr userDrawn="1"/>
         </p:nvSpPr>
@@ -19472,7 +19560,7 @@
       </p:sp>
       <p:sp>
         <p:nvSpPr>
-          <p:cNvPr id="1074943548" name="Rectangle 411"/>
+          <p:cNvPr id="1189626488" name="Rectangle 411"/>
           <p:cNvSpPr/>
           <p:nvPr userDrawn="1"/>
         </p:nvSpPr>
@@ -19494,7 +19582,7 @@
       </p:sp>
       <p:sp>
         <p:nvSpPr>
-          <p:cNvPr id="606312693" name="Rectangle 416"/>
+          <p:cNvPr id="39291444" name="Rectangle 416"/>
           <p:cNvSpPr/>
           <p:nvPr userDrawn="1"/>
         </p:nvSpPr>
@@ -19520,7 +19608,7 @@
       </p:sp>
       <p:sp>
         <p:nvSpPr>
-          <p:cNvPr id="1496481574" name="Rectangle 417"/>
+          <p:cNvPr id="1706129274" name="Rectangle 417"/>
           <p:cNvSpPr/>
           <p:nvPr userDrawn="1"/>
         </p:nvSpPr>
@@ -19546,7 +19634,7 @@
       </p:sp>
       <p:sp>
         <p:nvSpPr>
-          <p:cNvPr id="722349349" name="Rectangle 418"/>
+          <p:cNvPr id="652382782" name="Rectangle 418"/>
           <p:cNvSpPr/>
           <p:nvPr userDrawn="1"/>
         </p:nvSpPr>
@@ -19572,7 +19660,7 @@
       </p:sp>
       <p:sp>
         <p:nvSpPr>
-          <p:cNvPr id="73040964" name="Rectangle 400"/>
+          <p:cNvPr id="2106105376" name="Rectangle 400"/>
           <p:cNvSpPr/>
           <p:nvPr userDrawn="1"/>
         </p:nvSpPr>
@@ -19594,7 +19682,7 @@
       </p:sp>
       <p:sp>
         <p:nvSpPr>
-          <p:cNvPr id="1303736940" name="Rectangle 405"/>
+          <p:cNvPr id="1254852071" name="Rectangle 405"/>
           <p:cNvSpPr/>
           <p:nvPr userDrawn="1"/>
         </p:nvSpPr>
@@ -19619,7 +19707,7 @@
       </p:sp>
       <p:sp>
         <p:nvSpPr>
-          <p:cNvPr id="593504585" name="Rectangle 406"/>
+          <p:cNvPr id="1465409046" name="Rectangle 406"/>
           <p:cNvSpPr/>
           <p:nvPr userDrawn="1"/>
         </p:nvSpPr>
@@ -19645,7 +19733,7 @@
       </p:sp>
       <p:sp>
         <p:nvSpPr>
-          <p:cNvPr id="1467042555" name="Rectangle 407"/>
+          <p:cNvPr id="962706740" name="Rectangle 407"/>
           <p:cNvSpPr/>
           <p:nvPr userDrawn="1"/>
         </p:nvSpPr>
@@ -19671,7 +19759,7 @@
       </p:sp>
       <p:sp>
         <p:nvSpPr>
-          <p:cNvPr id="1120378806" name="Rectangle 389"/>
+          <p:cNvPr id="234553093" name="Rectangle 389"/>
           <p:cNvSpPr/>
           <p:nvPr userDrawn="1"/>
         </p:nvSpPr>
@@ -19693,7 +19781,7 @@
       </p:sp>
       <p:sp>
         <p:nvSpPr>
-          <p:cNvPr id="115946219" name="Rectangle 394"/>
+          <p:cNvPr id="1252379089" name="Rectangle 394"/>
           <p:cNvSpPr/>
           <p:nvPr userDrawn="1"/>
         </p:nvSpPr>
@@ -19719,7 +19807,7 @@
       </p:sp>
       <p:sp>
         <p:nvSpPr>
-          <p:cNvPr id="649766582" name="Rectangle 395"/>
+          <p:cNvPr id="1046696619" name="Rectangle 395"/>
           <p:cNvSpPr/>
           <p:nvPr userDrawn="1"/>
         </p:nvSpPr>
@@ -19745,7 +19833,7 @@
       </p:sp>
       <p:sp>
         <p:nvSpPr>
-          <p:cNvPr id="355135417" name="Rectangle 396"/>
+          <p:cNvPr id="1102024314" name="Rectangle 396"/>
           <p:cNvSpPr/>
           <p:nvPr userDrawn="1"/>
         </p:nvSpPr>
@@ -19771,7 +19859,7 @@
       </p:sp>
       <p:sp>
         <p:nvSpPr>
-          <p:cNvPr id="1213530682" name="Rectangle 378"/>
+          <p:cNvPr id="121436638" name="Rectangle 378"/>
           <p:cNvSpPr/>
           <p:nvPr userDrawn="1"/>
         </p:nvSpPr>
@@ -19793,7 +19881,7 @@
       </p:sp>
       <p:sp>
         <p:nvSpPr>
-          <p:cNvPr id="1213443147" name="Rectangle 383"/>
+          <p:cNvPr id="1188771263" name="Rectangle 383"/>
           <p:cNvSpPr/>
           <p:nvPr userDrawn="1"/>
         </p:nvSpPr>
@@ -19819,7 +19907,7 @@
       </p:sp>
       <p:sp>
         <p:nvSpPr>
-          <p:cNvPr id="1511581597" name="Rectangle 384"/>
+          <p:cNvPr id="1691101282" name="Rectangle 384"/>
           <p:cNvSpPr/>
           <p:nvPr userDrawn="1"/>
         </p:nvSpPr>
@@ -19845,7 +19933,7 @@
       </p:sp>
       <p:sp>
         <p:nvSpPr>
-          <p:cNvPr id="1701170210" name="Rectangle 385"/>
+          <p:cNvPr id="283642413" name="Rectangle 385"/>
           <p:cNvSpPr/>
           <p:nvPr userDrawn="1"/>
         </p:nvSpPr>
@@ -19871,7 +19959,7 @@
       </p:sp>
       <p:sp>
         <p:nvSpPr>
-          <p:cNvPr id="2092052410" name="Rectangle 365"/>
+          <p:cNvPr id="1665130343" name="Rectangle 365"/>
           <p:cNvSpPr/>
           <p:nvPr userDrawn="1"/>
         </p:nvSpPr>
@@ -19893,7 +19981,7 @@
       </p:sp>
       <p:sp>
         <p:nvSpPr>
-          <p:cNvPr id="1882397914" name="Rectangle 369"/>
+          <p:cNvPr id="156444661" name="Rectangle 369"/>
           <p:cNvSpPr/>
           <p:nvPr userDrawn="1"/>
         </p:nvSpPr>
@@ -19919,7 +20007,7 @@
       </p:sp>
       <p:sp>
         <p:nvSpPr>
-          <p:cNvPr id="1691414361" name="Rectangle 370"/>
+          <p:cNvPr id="952652394" name="Rectangle 370"/>
           <p:cNvSpPr/>
           <p:nvPr userDrawn="1"/>
         </p:nvSpPr>
@@ -19945,7 +20033,7 @@
       </p:sp>
       <p:sp>
         <p:nvSpPr>
-          <p:cNvPr id="1086156112" name="Text Placeholder 2"/>
+          <p:cNvPr id="2112112058" name="Text Placeholder 2"/>
           <p:cNvSpPr>
             <a:spLocks noGrp="1"/>
           </p:cNvSpPr>
@@ -20021,7 +20109,7 @@
       </p:sp>
       <p:sp>
         <p:nvSpPr>
-          <p:cNvPr id="1882415275" name="Title 1"/>
+          <p:cNvPr id="378842454" name="Title 1"/>
           <p:cNvSpPr>
             <a:spLocks noGrp="1"/>
           </p:cNvSpPr>
@@ -20062,7 +20150,7 @@
       </p:sp>
       <p:sp>
         <p:nvSpPr>
-          <p:cNvPr id="277133721" name="Slide Number Placeholder 5"/>
+          <p:cNvPr id="886660150" name="Slide Number Placeholder 5"/>
           <p:cNvSpPr>
             <a:spLocks noGrp="1"/>
           </p:cNvSpPr>
@@ -20103,7 +20191,7 @@
       </p:sp>
       <p:sp>
         <p:nvSpPr>
-          <p:cNvPr id="810463315" name="Date Placeholder 3"/>
+          <p:cNvPr id="2077474585" name="Date Placeholder 3"/>
           <p:cNvSpPr>
             <a:spLocks noGrp="1"/>
           </p:cNvSpPr>
@@ -20147,7 +20235,7 @@
       </p:sp>
       <p:sp>
         <p:nvSpPr>
-          <p:cNvPr id="1844594267" name="Footer Placeholder 4"/>
+          <p:cNvPr id="302426193" name="Footer Placeholder 4"/>
           <p:cNvSpPr>
             <a:spLocks noGrp="1"/>
           </p:cNvSpPr>
@@ -20201,6 +20289,7 @@
     <p:sldLayoutId id="2147483670" r:id="rId10"/>
     <p:sldLayoutId id="2147483671" r:id="rId11"/>
   </p:sldLayoutIdLst>
+  <p:hf dt="0" ftr="0" hdr="0" sldNum="1"/>
   <p:txStyles>
     <p:titleStyle>
       <a:lvl1pPr algn="ctr" defTabSz="914400" rtl="0">
@@ -20485,7 +20574,7 @@
       </p:grpSpPr>
       <p:sp>
         <p:nvSpPr>
-          <p:cNvPr id="332935154" name="Title 1"/>
+          <p:cNvPr id="964126364" name="Title 1"/>
           <p:cNvSpPr>
             <a:spLocks noGrp="1"/>
           </p:cNvSpPr>
@@ -20548,7 +20637,7 @@
       </p:sp>
       <p:sp>
         <p:nvSpPr>
-          <p:cNvPr id="870858404" name=""/>
+          <p:cNvPr id="617368235" name=""/>
           <p:cNvSpPr txBox="1"/>
           <p:nvPr/>
         </p:nvSpPr>
@@ -20590,7 +20679,7 @@
       </p:sp>
       <p:sp>
         <p:nvSpPr>
-          <p:cNvPr id="510480173" name=""/>
+          <p:cNvPr id="949816114" name=""/>
           <p:cNvSpPr txBox="1"/>
           <p:nvPr/>
         </p:nvSpPr>
@@ -20626,6 +20715,32 @@
               <a:rPr lang="pt-PT"/>
               <a:t>Diogo Novais, Nº70118</a:t>
             </a:r>
+            <a:endParaRPr/>
+          </a:p>
+        </p:txBody>
+      </p:sp>
+      <p:sp>
+        <p:nvSpPr>
+          <p:cNvPr id="901455272" name="Slide Number Placeholder 17"/>
+          <p:cNvSpPr>
+            <a:spLocks noGrp="1"/>
+          </p:cNvSpPr>
+          <p:nvPr>
+            <p:ph type="sldNum" sz="quarter" idx="12"/>
+          </p:nvPr>
+        </p:nvSpPr>
+        <p:spPr bwMode="auto"/>
+        <p:txBody>
+          <a:bodyPr/>
+          <a:lstStyle/>
+          <a:p>
+            <a:pPr>
+              <a:defRPr/>
+            </a:pPr>
+            <a:fld id="{C5AB40AA-0616-3DB7-EC84-0FFB1D1150B5}" type="slidenum">
+              <a:rPr/>
+              <a:t/>
+            </a:fld>
             <a:endParaRPr/>
           </a:p>
         </p:txBody>
@@ -20665,7 +20780,7 @@
       </p:grpSpPr>
       <p:sp>
         <p:nvSpPr>
-          <p:cNvPr id="741612961" name="Title 1"/>
+          <p:cNvPr id="1164065420" name="Title 1"/>
           <p:cNvSpPr>
             <a:spLocks noGrp="1"/>
           </p:cNvSpPr>
@@ -20674,20 +20789,22 @@
           </p:nvPr>
         </p:nvSpPr>
         <p:spPr bwMode="auto">
-          <a:xfrm>
-            <a:off x="2676486" y="864219"/>
-            <a:ext cx="6750076" cy="856126"/>
+          <a:xfrm flipH="0" flipV="0">
+            <a:off x="2667992" y="851346"/>
+            <a:ext cx="6750077" cy="783347"/>
           </a:xfrm>
         </p:spPr>
         <p:txBody>
-          <a:bodyPr/>
+          <a:bodyPr vertOverflow="overflow" horzOverflow="overflow" vert="horz" wrap="square" lIns="91440" tIns="45720" rIns="91440" bIns="45720" numCol="1" spcCol="0" rtlCol="0" fromWordArt="0" anchor="ctr" anchorCtr="0" forceAA="0" upright="0" compatLnSpc="0">
+            <a:normAutofit fontScale="95000" lnSpcReduction="1000"/>
+          </a:bodyPr>
           <a:lstStyle/>
           <a:p>
             <a:pPr>
               <a:defRPr/>
             </a:pPr>
             <a:r>
-              <a:rPr lang="en-GB" sz="3300" b="0" i="0" u="none" strike="noStrike" cap="none" spc="0">
+              <a:rPr lang="pt-PT" sz="3300" b="0" i="0" u="none" strike="noStrike" cap="none" spc="0">
                 <a:solidFill>
                   <a:schemeClr val="tx1"/>
                 </a:solidFill>
@@ -20695,7 +20812,18 @@
                 <a:ea typeface="Arial"/>
                 <a:cs typeface="Arial"/>
               </a:rPr>
-              <a:t>GAN-Based Models</a:t>
+              <a:t>DCED</a:t>
+            </a:r>
+            <a:r>
+              <a:rPr lang="en-GB" sz="3300" b="0" i="0" u="none" strike="noStrike" cap="none" spc="0">
+                <a:solidFill>
+                  <a:schemeClr val="tx1"/>
+                </a:solidFill>
+                <a:latin typeface="Arial"/>
+                <a:ea typeface="Arial"/>
+                <a:cs typeface="Arial"/>
+              </a:rPr>
+              <a:t> Models</a:t>
             </a:r>
             <a:endParaRPr/>
           </a:p>
@@ -20703,20 +20831,20 @@
       </p:sp>
       <p:pic>
         <p:nvPicPr>
-          <p:cNvPr id="1905338848" name=""/>
+          <p:cNvPr id="413240769" name=""/>
           <p:cNvPicPr>
             <a:picLocks noChangeAspect="1"/>
           </p:cNvPicPr>
           <p:nvPr/>
         </p:nvPicPr>
-        <p:blipFill>
+        <p:blipFill rotWithShape="1">
           <a:blip r:embed="rId3"/>
           <a:stretch/>
         </p:blipFill>
         <p:spPr bwMode="auto">
           <a:xfrm flipH="0" flipV="0">
-            <a:off x="1437626" y="2120290"/>
-            <a:ext cx="9316747" cy="4240581"/>
+            <a:off x="2667993" y="1690687"/>
+            <a:ext cx="6856011" cy="4246090"/>
           </a:xfrm>
           <a:prstGeom prst="rect">
             <a:avLst/>
@@ -20725,7 +20853,7 @@
       </p:pic>
       <p:sp>
         <p:nvSpPr>
-          <p:cNvPr id="432700650" name=""/>
+          <p:cNvPr id="1906576958" name=""/>
           <p:cNvSpPr txBox="1"/>
           <p:nvPr/>
         </p:nvSpPr>
@@ -20762,6 +20890,73 @@
               <a:t>DEEC\FCT\UNL - TAPDI</a:t>
             </a:r>
             <a:endParaRPr lang="pt-PT"/>
+          </a:p>
+        </p:txBody>
+      </p:sp>
+      <p:sp>
+        <p:nvSpPr>
+          <p:cNvPr id="776515354" name=""/>
+          <p:cNvSpPr/>
+          <p:nvPr/>
+        </p:nvSpPr>
+        <p:spPr bwMode="auto">
+          <a:xfrm flipH="0" flipV="0">
+            <a:off x="4776882" y="6360870"/>
+            <a:ext cx="7683395" cy="274679"/>
+          </a:xfrm>
+        </p:spPr>
+        <p:txBody>
+          <a:bodyPr rot="0" spcFirstLastPara="0" vertOverflow="overflow" horzOverflow="overflow" vert="horz" wrap="square" lIns="91440" tIns="45720" rIns="91440" bIns="45720" numCol="1" spcCol="0" rtlCol="0" fromWordArt="0" anchor="t" anchorCtr="0" forceAA="0" upright="0" compatLnSpc="1">
+            <a:prstTxWarp prst="textNoShape"/>
+            <a:spAutoFit/>
+          </a:bodyPr>
+          <a:p>
+            <a:pPr>
+              <a:defRPr/>
+            </a:pPr>
+            <a:r>
+              <a:rPr sz="1200" b="0" i="0" u="none">
+                <a:solidFill>
+                  <a:srgbClr val="000000"/>
+                </a:solidFill>
+                <a:latin typeface="Times New Roman"/>
+                <a:ea typeface="Times New Roman"/>
+                <a:cs typeface="Times New Roman"/>
+              </a:rPr>
+              <a:t>Deep Learning Approaches Applied to Remote Sensing Datasets for Road Extraction: A State-Of-The-Art Review [10]</a:t>
+            </a:r>
+            <a:endParaRPr/>
+          </a:p>
+        </p:txBody>
+      </p:sp>
+      <p:sp>
+        <p:nvSpPr>
+          <p:cNvPr id="545410141" name="Slide Number Placeholder 17"/>
+          <p:cNvSpPr>
+            <a:spLocks noGrp="1"/>
+          </p:cNvSpPr>
+          <p:nvPr>
+            <p:ph type="sldNum" sz="quarter" idx="12"/>
+          </p:nvPr>
+        </p:nvSpPr>
+        <p:spPr bwMode="auto">
+          <a:xfrm>
+            <a:off x="5190394" y="6132834"/>
+            <a:ext cx="952633" cy="365124"/>
+          </a:xfrm>
+        </p:spPr>
+        <p:txBody>
+          <a:bodyPr/>
+          <a:lstStyle/>
+          <a:p>
+            <a:pPr>
+              <a:defRPr/>
+            </a:pPr>
+            <a:fld id="{946B795E-394D-7E59-8EAA-F92606E756DF}" type="slidenum">
+              <a:rPr/>
+              <a:t/>
+            </a:fld>
+            <a:endParaRPr/>
           </a:p>
         </p:txBody>
       </p:sp>
@@ -20800,7 +20995,7 @@
       </p:grpSpPr>
       <p:sp>
         <p:nvSpPr>
-          <p:cNvPr id="1031584317" name="Title 1"/>
+          <p:cNvPr id="797795995" name="Title 1"/>
           <p:cNvSpPr>
             <a:spLocks noGrp="1"/>
           </p:cNvSpPr>
@@ -20810,8 +21005,8 @@
         </p:nvSpPr>
         <p:spPr bwMode="auto">
           <a:xfrm>
-            <a:off x="2676485" y="864218"/>
-            <a:ext cx="6750075" cy="856125"/>
+            <a:off x="2676486" y="864219"/>
+            <a:ext cx="6750076" cy="856126"/>
           </a:xfrm>
         </p:spPr>
         <p:txBody>
@@ -20836,16 +21031,38 @@
           </a:p>
         </p:txBody>
       </p:sp>
-      <p:sp>
-        <p:nvSpPr>
-          <p:cNvPr id="1658760849" name=""/>
+      <p:pic>
+        <p:nvPicPr>
+          <p:cNvPr id="1478335954" name=""/>
+          <p:cNvPicPr>
+            <a:picLocks noChangeAspect="1"/>
+          </p:cNvPicPr>
+          <p:nvPr/>
+        </p:nvPicPr>
+        <p:blipFill rotWithShape="1">
+          <a:blip r:embed="rId3"/>
+          <a:stretch/>
+        </p:blipFill>
+        <p:spPr bwMode="auto">
+          <a:xfrm flipH="0" flipV="0">
+            <a:off x="1437626" y="2120290"/>
+            <a:ext cx="9316747" cy="4240581"/>
+          </a:xfrm>
+          <a:prstGeom prst="rect">
+            <a:avLst/>
+          </a:prstGeom>
+        </p:spPr>
+      </p:pic>
+      <p:sp>
+        <p:nvSpPr>
+          <p:cNvPr id="1396295483" name=""/>
           <p:cNvSpPr txBox="1"/>
           <p:nvPr/>
         </p:nvSpPr>
         <p:spPr bwMode="auto">
           <a:xfrm rot="0" flipH="0" flipV="0">
-            <a:off x="27058" y="5929671"/>
-            <a:ext cx="2660004" cy="640438"/>
+            <a:off x="27059" y="5929672"/>
+            <a:ext cx="2660004" cy="640439"/>
           </a:xfrm>
           <a:prstGeom prst="rect">
             <a:avLst/>
@@ -20878,50 +21095,73 @@
           </a:p>
         </p:txBody>
       </p:sp>
-      <p:pic>
-        <p:nvPicPr>
-          <p:cNvPr id="39912288" name=""/>
-          <p:cNvPicPr>
-            <a:picLocks noChangeAspect="1"/>
-          </p:cNvPicPr>
+      <p:sp>
+        <p:nvSpPr>
+          <p:cNvPr id="268667988" name=""/>
+          <p:cNvSpPr/>
           <p:nvPr/>
-        </p:nvPicPr>
-        <p:blipFill>
-          <a:blip r:embed="rId3"/>
-          <a:stretch/>
-        </p:blipFill>
+        </p:nvSpPr>
         <p:spPr bwMode="auto">
           <a:xfrm flipH="0" flipV="0">
-            <a:off x="614588" y="1720344"/>
-            <a:ext cx="7188698" cy="2950819"/>
+            <a:off x="4776883" y="6360870"/>
+            <a:ext cx="7683036" cy="274679"/>
           </a:xfrm>
-          <a:prstGeom prst="rect">
-            <a:avLst/>
-          </a:prstGeom>
         </p:spPr>
-      </p:pic>
-      <p:pic>
-        <p:nvPicPr>
-          <p:cNvPr id="1956119090" name=""/>
-          <p:cNvPicPr>
-            <a:picLocks noChangeAspect="1"/>
-          </p:cNvPicPr>
-          <p:nvPr/>
-        </p:nvPicPr>
-        <p:blipFill>
-          <a:blip r:embed="rId4"/>
-          <a:stretch/>
-        </p:blipFill>
+        <p:txBody>
+          <a:bodyPr rot="0" spcFirstLastPara="0" vertOverflow="overflow" horzOverflow="overflow" vert="horz" wrap="square" lIns="91440" tIns="45720" rIns="91440" bIns="45720" numCol="1" spcCol="0" rtlCol="0" fromWordArt="0" anchor="t" anchorCtr="0" forceAA="0" upright="0" compatLnSpc="1">
+            <a:prstTxWarp prst="textNoShape"/>
+            <a:spAutoFit/>
+          </a:bodyPr>
+          <a:p>
+            <a:pPr>
+              <a:defRPr/>
+            </a:pPr>
+            <a:r>
+              <a:rPr sz="1200" b="0" i="0" u="none">
+                <a:solidFill>
+                  <a:srgbClr val="000000"/>
+                </a:solidFill>
+                <a:latin typeface="Times New Roman"/>
+                <a:ea typeface="Times New Roman"/>
+                <a:cs typeface="Times New Roman"/>
+              </a:rPr>
+              <a:t>Deep Learning Approaches Applied to Remote Sensing Datasets for Road Extraction: A State-Of-The-Art Review [10]</a:t>
+            </a:r>
+            <a:endParaRPr/>
+          </a:p>
+        </p:txBody>
+      </p:sp>
+      <p:sp>
+        <p:nvSpPr>
+          <p:cNvPr id="987393860" name="Slide Number Placeholder 17"/>
+          <p:cNvSpPr>
+            <a:spLocks noGrp="1"/>
+          </p:cNvSpPr>
+          <p:nvPr>
+            <p:ph type="sldNum" sz="quarter" idx="12"/>
+          </p:nvPr>
+        </p:nvSpPr>
         <p:spPr bwMode="auto">
-          <a:xfrm flipH="0" flipV="0">
-            <a:off x="6448294" y="3793756"/>
-            <a:ext cx="5739821" cy="2776354"/>
+          <a:xfrm>
+            <a:off x="5190394" y="6132834"/>
+            <a:ext cx="952633" cy="365124"/>
           </a:xfrm>
-          <a:prstGeom prst="rect">
-            <a:avLst/>
-          </a:prstGeom>
         </p:spPr>
-      </p:pic>
+        <p:txBody>
+          <a:bodyPr/>
+          <a:lstStyle/>
+          <a:p>
+            <a:pPr>
+              <a:defRPr/>
+            </a:pPr>
+            <a:fld id="{919EC5A2-1700-C35E-BC4D-CDCD949A23CC}" type="slidenum">
+              <a:rPr/>
+              <a:t/>
+            </a:fld>
+            <a:endParaRPr/>
+          </a:p>
+        </p:txBody>
+      </p:sp>
     </p:spTree>
   </p:cSld>
   <p:clrMapOvr>
@@ -20957,7 +21197,7 @@
       </p:grpSpPr>
       <p:sp>
         <p:nvSpPr>
-          <p:cNvPr id="1535372877" name="Title 1"/>
+          <p:cNvPr id="1068748275" name="Title 1"/>
           <p:cNvSpPr>
             <a:spLocks noGrp="1"/>
           </p:cNvSpPr>
@@ -20965,7 +21205,12 @@
             <p:ph type="title"/>
           </p:nvPr>
         </p:nvSpPr>
-        <p:spPr bwMode="auto"/>
+        <p:spPr bwMode="auto">
+          <a:xfrm>
+            <a:off x="2676485" y="864218"/>
+            <a:ext cx="6750075" cy="856125"/>
+          </a:xfrm>
+        </p:spPr>
         <p:txBody>
           <a:bodyPr/>
           <a:lstStyle/>
@@ -20974,34 +21219,78 @@
               <a:defRPr/>
             </a:pPr>
             <a:r>
-              <a:rPr lang="pt-PT"/>
-              <a:t>Error </a:t>
+              <a:rPr lang="en-GB" sz="3300" b="0" i="0" u="none" strike="noStrike" cap="none" spc="0">
+                <a:solidFill>
+                  <a:schemeClr val="tx1"/>
+                </a:solidFill>
+                <a:latin typeface="Arial"/>
+                <a:ea typeface="Arial"/>
+                <a:cs typeface="Arial"/>
+              </a:rPr>
+              <a:t>GAN-Based Models</a:t>
             </a:r>
+            <a:endParaRPr/>
+          </a:p>
+        </p:txBody>
+      </p:sp>
+      <p:sp>
+        <p:nvSpPr>
+          <p:cNvPr id="331181384" name=""/>
+          <p:cNvSpPr txBox="1"/>
+          <p:nvPr/>
+        </p:nvSpPr>
+        <p:spPr bwMode="auto">
+          <a:xfrm rot="0" flipH="0" flipV="0">
+            <a:off x="27058" y="5929671"/>
+            <a:ext cx="2660004" cy="640438"/>
+          </a:xfrm>
+          <a:prstGeom prst="rect">
+            <a:avLst/>
+          </a:prstGeom>
+          <a:noFill/>
+        </p:spPr>
+        <p:txBody>
+          <a:bodyPr vertOverflow="overflow" horzOverflow="overflow" vert="horz" wrap="none" lIns="91440" tIns="45720" rIns="91440" bIns="45720" numCol="1" spcCol="0" rtlCol="0" fromWordArt="0" anchor="t" anchorCtr="0" forceAA="0" upright="0" compatLnSpc="0">
+            <a:spAutoFit/>
+          </a:bodyPr>
+          <a:p>
+            <a:pPr>
+              <a:defRPr/>
+            </a:pPr>
             <a:r>
               <a:rPr lang="pt-PT"/>
-              <a:t>Measurement Methods</a:t>
+              <a:t>2/12/2025</a:t>
             </a:r>
             <a:endParaRPr/>
+          </a:p>
+          <a:p>
+            <a:pPr>
+              <a:defRPr/>
+            </a:pPr>
+            <a:r>
+              <a:rPr lang="pt-PT"/>
+              <a:t>DEEC\FCT\UNL - TAPDI</a:t>
+            </a:r>
+            <a:endParaRPr lang="pt-PT"/>
           </a:p>
         </p:txBody>
       </p:sp>
       <p:pic>
         <p:nvPicPr>
-          <p:cNvPr id="1906406636" name=""/>
+          <p:cNvPr id="1504070641" name=""/>
           <p:cNvPicPr>
             <a:picLocks noChangeAspect="1"/>
           </p:cNvPicPr>
           <p:nvPr/>
         </p:nvPicPr>
-        <p:blipFill>
+        <p:blipFill rotWithShape="1">
           <a:blip r:embed="rId3"/>
-          <a:srcRect l="0" t="0" r="17506" b="0"/>
           <a:stretch/>
         </p:blipFill>
         <p:spPr bwMode="auto">
           <a:xfrm flipH="0" flipV="0">
-            <a:off x="276753" y="1421341"/>
-            <a:ext cx="3402308" cy="4238624"/>
+            <a:off x="614588" y="1720344"/>
+            <a:ext cx="7188698" cy="2950819"/>
           </a:xfrm>
           <a:prstGeom prst="rect">
             <a:avLst/>
@@ -21010,94 +21299,57 @@
       </p:pic>
       <p:pic>
         <p:nvPicPr>
-          <p:cNvPr id="813723766" name=""/>
+          <p:cNvPr id="1100683561" name=""/>
           <p:cNvPicPr>
             <a:picLocks noChangeAspect="1"/>
           </p:cNvPicPr>
           <p:nvPr/>
         </p:nvPicPr>
-        <p:blipFill>
+        <p:blipFill rotWithShape="1">
           <a:blip r:embed="rId4"/>
-          <a:srcRect l="0" t="0" r="10218" b="0"/>
           <a:stretch/>
         </p:blipFill>
         <p:spPr bwMode="auto">
           <a:xfrm flipH="0" flipV="0">
-            <a:off x="3883553" y="1421341"/>
-            <a:ext cx="3711341" cy="4200525"/>
+            <a:off x="6448294" y="3793756"/>
+            <a:ext cx="5739821" cy="2776354"/>
           </a:xfrm>
           <a:prstGeom prst="rect">
             <a:avLst/>
           </a:prstGeom>
         </p:spPr>
       </p:pic>
-      <p:pic>
-        <p:nvPicPr>
-          <p:cNvPr id="1138058331" name=""/>
-          <p:cNvPicPr>
-            <a:picLocks noChangeAspect="1"/>
-          </p:cNvPicPr>
-          <p:nvPr/>
-        </p:nvPicPr>
-        <p:blipFill>
-          <a:blip r:embed="rId5"/>
-          <a:srcRect l="0" t="0" r="2373" b="39545"/>
-          <a:stretch/>
-        </p:blipFill>
+      <p:sp>
+        <p:nvSpPr>
+          <p:cNvPr id="1740121934" name="Slide Number Placeholder 17"/>
+          <p:cNvSpPr>
+            <a:spLocks noGrp="1"/>
+          </p:cNvSpPr>
+          <p:nvPr>
+            <p:ph type="sldNum" sz="quarter" idx="12"/>
+          </p:nvPr>
+        </p:nvSpPr>
         <p:spPr bwMode="auto">
-          <a:xfrm flipH="0" flipV="0">
-            <a:off x="7594895" y="3048322"/>
-            <a:ext cx="4463503" cy="984662"/>
+          <a:xfrm>
+            <a:off x="5190394" y="6132834"/>
+            <a:ext cx="952633" cy="365124"/>
           </a:xfrm>
-          <a:prstGeom prst="rect">
-            <a:avLst/>
-          </a:prstGeom>
         </p:spPr>
-      </p:pic>
-      <p:pic>
-        <p:nvPicPr>
-          <p:cNvPr id="1368280299" name=""/>
-          <p:cNvPicPr>
-            <a:picLocks noChangeAspect="1"/>
-          </p:cNvPicPr>
-          <p:nvPr/>
-        </p:nvPicPr>
-        <p:blipFill>
-          <a:blip r:embed="rId6"/>
-          <a:stretch/>
-        </p:blipFill>
-        <p:spPr bwMode="auto">
-          <a:xfrm flipH="0" flipV="0">
-            <a:off x="11486719" y="2825505"/>
-            <a:ext cx="847724" cy="958715"/>
-          </a:xfrm>
-          <a:prstGeom prst="rect">
-            <a:avLst/>
-          </a:prstGeom>
-        </p:spPr>
-      </p:pic>
-      <p:pic>
-        <p:nvPicPr>
-          <p:cNvPr id="1988416958" name=""/>
-          <p:cNvPicPr>
-            <a:picLocks noChangeAspect="1"/>
-          </p:cNvPicPr>
-          <p:nvPr/>
-        </p:nvPicPr>
-        <p:blipFill>
-          <a:blip r:embed="rId6"/>
-          <a:stretch/>
-        </p:blipFill>
-        <p:spPr bwMode="auto">
-          <a:xfrm flipH="0" flipV="0">
-            <a:off x="10309346" y="4087090"/>
-            <a:ext cx="847724" cy="958714"/>
-          </a:xfrm>
-          <a:prstGeom prst="rect">
-            <a:avLst/>
-          </a:prstGeom>
-        </p:spPr>
-      </p:pic>
+        <p:txBody>
+          <a:bodyPr/>
+          <a:lstStyle/>
+          <a:p>
+            <a:pPr>
+              <a:defRPr/>
+            </a:pPr>
+            <a:fld id="{67623634-E19B-EF14-8B37-A5E75D247095}" type="slidenum">
+              <a:rPr/>
+              <a:t/>
+            </a:fld>
+            <a:endParaRPr/>
+          </a:p>
+        </p:txBody>
+      </p:sp>
     </p:spTree>
   </p:cSld>
   <p:clrMapOvr>
@@ -21131,83 +21383,180 @@
           <a:chExt cx="0" cy="0"/>
         </a:xfrm>
       </p:grpSpPr>
+      <p:sp>
+        <p:nvSpPr>
+          <p:cNvPr id="592377826" name="Title 1"/>
+          <p:cNvSpPr>
+            <a:spLocks noGrp="1"/>
+          </p:cNvSpPr>
+          <p:nvPr>
+            <p:ph type="title"/>
+          </p:nvPr>
+        </p:nvSpPr>
+        <p:spPr bwMode="auto"/>
+        <p:txBody>
+          <a:bodyPr/>
+          <a:lstStyle/>
+          <a:p>
+            <a:pPr>
+              <a:defRPr/>
+            </a:pPr>
+            <a:r>
+              <a:rPr lang="pt-PT"/>
+              <a:t>Error </a:t>
+            </a:r>
+            <a:r>
+              <a:rPr lang="pt-PT"/>
+              <a:t>Measurement Methods</a:t>
+            </a:r>
+            <a:endParaRPr/>
+          </a:p>
+        </p:txBody>
+      </p:sp>
       <p:pic>
         <p:nvPicPr>
-          <p:cNvPr id="576485351" name=""/>
+          <p:cNvPr id="1192970967" name=""/>
           <p:cNvPicPr>
             <a:picLocks noChangeAspect="1"/>
           </p:cNvPicPr>
           <p:nvPr/>
         </p:nvPicPr>
-        <p:blipFill>
+        <p:blipFill rotWithShape="1">
           <a:blip r:embed="rId3"/>
+          <a:srcRect l="0" t="0" r="17506" b="0"/>
           <a:stretch/>
         </p:blipFill>
         <p:spPr bwMode="auto">
           <a:xfrm flipH="0" flipV="0">
-            <a:off x="-13515" y="20964"/>
-            <a:ext cx="7732664" cy="3484764"/>
+            <a:off x="276753" y="1421341"/>
+            <a:ext cx="3402308" cy="4238624"/>
           </a:xfrm>
           <a:prstGeom prst="rect">
             <a:avLst/>
           </a:prstGeom>
         </p:spPr>
       </p:pic>
-      <p:sp>
-        <p:nvSpPr>
-          <p:cNvPr id="951800065" name="Title 1"/>
-          <p:cNvSpPr>
-            <a:spLocks noGrp="1"/>
-          </p:cNvSpPr>
-          <p:nvPr>
-            <p:ph type="title"/>
-          </p:nvPr>
-        </p:nvSpPr>
-        <p:spPr bwMode="auto">
-          <a:xfrm flipH="0" flipV="0">
-            <a:off x="8838437" y="1362603"/>
-            <a:ext cx="2486709" cy="1190624"/>
-          </a:xfrm>
-        </p:spPr>
-        <p:txBody>
-          <a:bodyPr vertOverflow="overflow" horzOverflow="overflow" vert="horz" wrap="square" lIns="91440" tIns="45720" rIns="91440" bIns="45720" numCol="1" spcCol="0" rtlCol="0" fromWordArt="0" anchor="ctr" anchorCtr="0" forceAA="0" upright="0" compatLnSpc="0">
-            <a:normAutofit/>
-          </a:bodyPr>
-          <a:lstStyle/>
-          <a:p>
-            <a:pPr>
-              <a:defRPr/>
-            </a:pPr>
-            <a:r>
-              <a:rPr/>
-              <a:t>Results</a:t>
-            </a:r>
-            <a:endParaRPr/>
-          </a:p>
-        </p:txBody>
-      </p:sp>
       <p:pic>
         <p:nvPicPr>
-          <p:cNvPr id="369093159" name=""/>
+          <p:cNvPr id="468662980" name=""/>
           <p:cNvPicPr>
             <a:picLocks noChangeAspect="1"/>
           </p:cNvPicPr>
           <p:nvPr/>
         </p:nvPicPr>
-        <p:blipFill>
+        <p:blipFill rotWithShape="1">
           <a:blip r:embed="rId4"/>
+          <a:srcRect l="0" t="0" r="10218" b="0"/>
           <a:stretch/>
         </p:blipFill>
         <p:spPr bwMode="auto">
           <a:xfrm flipH="0" flipV="0">
-            <a:off x="5034157" y="3429000"/>
-            <a:ext cx="7150768" cy="3440641"/>
+            <a:off x="3883553" y="1421341"/>
+            <a:ext cx="3711341" cy="4200525"/>
           </a:xfrm>
           <a:prstGeom prst="rect">
             <a:avLst/>
           </a:prstGeom>
         </p:spPr>
       </p:pic>
+      <p:pic>
+        <p:nvPicPr>
+          <p:cNvPr id="2102913142" name=""/>
+          <p:cNvPicPr>
+            <a:picLocks noChangeAspect="1"/>
+          </p:cNvPicPr>
+          <p:nvPr/>
+        </p:nvPicPr>
+        <p:blipFill rotWithShape="1">
+          <a:blip r:embed="rId5"/>
+          <a:srcRect l="0" t="0" r="2373" b="39545"/>
+          <a:stretch/>
+        </p:blipFill>
+        <p:spPr bwMode="auto">
+          <a:xfrm flipH="0" flipV="0">
+            <a:off x="7594895" y="3048322"/>
+            <a:ext cx="4463503" cy="984662"/>
+          </a:xfrm>
+          <a:prstGeom prst="rect">
+            <a:avLst/>
+          </a:prstGeom>
+        </p:spPr>
+      </p:pic>
+      <p:pic>
+        <p:nvPicPr>
+          <p:cNvPr id="835597172" name=""/>
+          <p:cNvPicPr>
+            <a:picLocks noChangeAspect="1"/>
+          </p:cNvPicPr>
+          <p:nvPr/>
+        </p:nvPicPr>
+        <p:blipFill rotWithShape="1">
+          <a:blip r:embed="rId6"/>
+          <a:stretch/>
+        </p:blipFill>
+        <p:spPr bwMode="auto">
+          <a:xfrm flipH="0" flipV="0">
+            <a:off x="11486719" y="2825505"/>
+            <a:ext cx="847724" cy="958715"/>
+          </a:xfrm>
+          <a:prstGeom prst="rect">
+            <a:avLst/>
+          </a:prstGeom>
+        </p:spPr>
+      </p:pic>
+      <p:pic>
+        <p:nvPicPr>
+          <p:cNvPr id="751937953" name=""/>
+          <p:cNvPicPr>
+            <a:picLocks noChangeAspect="1"/>
+          </p:cNvPicPr>
+          <p:nvPr/>
+        </p:nvPicPr>
+        <p:blipFill rotWithShape="1">
+          <a:blip r:embed="rId6"/>
+          <a:stretch/>
+        </p:blipFill>
+        <p:spPr bwMode="auto">
+          <a:xfrm flipH="0" flipV="0">
+            <a:off x="10309346" y="4087090"/>
+            <a:ext cx="847724" cy="958714"/>
+          </a:xfrm>
+          <a:prstGeom prst="rect">
+            <a:avLst/>
+          </a:prstGeom>
+        </p:spPr>
+      </p:pic>
+      <p:sp>
+        <p:nvSpPr>
+          <p:cNvPr id="2004608138" name="Slide Number Placeholder 17"/>
+          <p:cNvSpPr>
+            <a:spLocks noGrp="1"/>
+          </p:cNvSpPr>
+          <p:nvPr>
+            <p:ph type="sldNum" sz="quarter" idx="12"/>
+          </p:nvPr>
+        </p:nvSpPr>
+        <p:spPr bwMode="auto">
+          <a:xfrm>
+            <a:off x="5190394" y="6132834"/>
+            <a:ext cx="952633" cy="365124"/>
+          </a:xfrm>
+        </p:spPr>
+        <p:txBody>
+          <a:bodyPr/>
+          <a:lstStyle/>
+          <a:p>
+            <a:pPr>
+              <a:defRPr/>
+            </a:pPr>
+            <a:fld id="{A0B9C187-0B7A-9BE9-0F91-63BD8625BBD0}" type="slidenum">
+              <a:rPr/>
+              <a:t/>
+            </a:fld>
+            <a:endParaRPr/>
+          </a:p>
+        </p:txBody>
+      </p:sp>
     </p:spTree>
   </p:cSld>
   <p:clrMapOvr>
@@ -21243,7 +21592,7 @@
       </p:grpSpPr>
       <p:sp>
         <p:nvSpPr>
-          <p:cNvPr id="324653000" name="Title 1"/>
+          <p:cNvPr id="100148206" name="Title 1"/>
           <p:cNvSpPr>
             <a:spLocks noGrp="1"/>
           </p:cNvSpPr>
@@ -21252,20 +21601,22 @@
           </p:nvPr>
         </p:nvSpPr>
         <p:spPr bwMode="auto">
-          <a:xfrm>
-            <a:off x="2676487" y="895327"/>
-            <a:ext cx="6750077" cy="856127"/>
+          <a:xfrm flipH="0" flipV="0">
+            <a:off x="8838437" y="1362603"/>
+            <a:ext cx="2486709" cy="1190624"/>
           </a:xfrm>
         </p:spPr>
         <p:txBody>
-          <a:bodyPr/>
+          <a:bodyPr vertOverflow="overflow" horzOverflow="overflow" vert="horz" wrap="square" lIns="91440" tIns="45720" rIns="91440" bIns="45720" numCol="1" spcCol="0" rtlCol="0" fromWordArt="0" anchor="ctr" anchorCtr="0" forceAA="0" upright="0" compatLnSpc="0">
+            <a:normAutofit/>
+          </a:bodyPr>
           <a:lstStyle/>
           <a:p>
             <a:pPr>
               <a:defRPr/>
             </a:pPr>
             <a:r>
-              <a:rPr lang="pt-PT"/>
+              <a:rPr/>
               <a:t>Results</a:t>
             </a:r>
             <a:endParaRPr/>
@@ -21274,26 +21625,79 @@
       </p:sp>
       <p:pic>
         <p:nvPicPr>
-          <p:cNvPr id="840198703" name=""/>
+          <p:cNvPr id="1043214361" name=""/>
           <p:cNvPicPr>
             <a:picLocks noChangeAspect="1"/>
           </p:cNvPicPr>
           <p:nvPr/>
         </p:nvPicPr>
-        <p:blipFill>
+        <p:blipFill rotWithShape="1">
           <a:blip r:embed="rId3"/>
           <a:stretch/>
         </p:blipFill>
         <p:spPr bwMode="auto">
-          <a:xfrm>
-            <a:off x="598464" y="1579476"/>
-            <a:ext cx="10906124" cy="4914900"/>
+          <a:xfrm flipH="0" flipV="0">
+            <a:off x="-3160" y="0"/>
+            <a:ext cx="8555658" cy="3429000"/>
           </a:xfrm>
           <a:prstGeom prst="rect">
             <a:avLst/>
           </a:prstGeom>
         </p:spPr>
       </p:pic>
+      <p:pic>
+        <p:nvPicPr>
+          <p:cNvPr id="1911959789" name=""/>
+          <p:cNvPicPr>
+            <a:picLocks noChangeAspect="1"/>
+          </p:cNvPicPr>
+          <p:nvPr/>
+        </p:nvPicPr>
+        <p:blipFill rotWithShape="1">
+          <a:blip r:embed="rId4"/>
+          <a:stretch/>
+        </p:blipFill>
+        <p:spPr bwMode="auto">
+          <a:xfrm flipH="0" flipV="0">
+            <a:off x="4274668" y="3429000"/>
+            <a:ext cx="7901412" cy="3445165"/>
+          </a:xfrm>
+          <a:prstGeom prst="rect">
+            <a:avLst/>
+          </a:prstGeom>
+        </p:spPr>
+      </p:pic>
+      <p:sp>
+        <p:nvSpPr>
+          <p:cNvPr id="554476479" name="Slide Number Placeholder 17"/>
+          <p:cNvSpPr>
+            <a:spLocks noGrp="1"/>
+          </p:cNvSpPr>
+          <p:nvPr>
+            <p:ph type="sldNum" sz="quarter" idx="12"/>
+          </p:nvPr>
+        </p:nvSpPr>
+        <p:spPr bwMode="auto">
+          <a:xfrm>
+            <a:off x="5190394" y="6132834"/>
+            <a:ext cx="952633" cy="365124"/>
+          </a:xfrm>
+        </p:spPr>
+        <p:txBody>
+          <a:bodyPr/>
+          <a:lstStyle/>
+          <a:p>
+            <a:pPr>
+              <a:defRPr/>
+            </a:pPr>
+            <a:fld id="{7FD2DEF3-138D-35C2-971D-3CEF2AFF68D6}" type="slidenum">
+              <a:rPr/>
+              <a:t/>
+            </a:fld>
+            <a:endParaRPr/>
+          </a:p>
+        </p:txBody>
+      </p:sp>
     </p:spTree>
   </p:cSld>
   <p:clrMapOvr>
@@ -21329,7 +21733,124 @@
       </p:grpSpPr>
       <p:sp>
         <p:nvSpPr>
-          <p:cNvPr id="1327826907" name="Title 1"/>
+          <p:cNvPr id="599523610" name="Title 1"/>
+          <p:cNvSpPr>
+            <a:spLocks noGrp="1"/>
+          </p:cNvSpPr>
+          <p:nvPr>
+            <p:ph type="title"/>
+          </p:nvPr>
+        </p:nvSpPr>
+        <p:spPr bwMode="auto">
+          <a:xfrm>
+            <a:off x="2676487" y="895327"/>
+            <a:ext cx="6750077" cy="856127"/>
+          </a:xfrm>
+        </p:spPr>
+        <p:txBody>
+          <a:bodyPr/>
+          <a:lstStyle/>
+          <a:p>
+            <a:pPr>
+              <a:defRPr/>
+            </a:pPr>
+            <a:r>
+              <a:rPr lang="pt-PT"/>
+              <a:t>Results</a:t>
+            </a:r>
+            <a:endParaRPr/>
+          </a:p>
+        </p:txBody>
+      </p:sp>
+      <p:pic>
+        <p:nvPicPr>
+          <p:cNvPr id="1564219621" name=""/>
+          <p:cNvPicPr>
+            <a:picLocks noChangeAspect="1"/>
+          </p:cNvPicPr>
+          <p:nvPr/>
+        </p:nvPicPr>
+        <p:blipFill rotWithShape="1">
+          <a:blip r:embed="rId3"/>
+          <a:stretch/>
+        </p:blipFill>
+        <p:spPr bwMode="auto">
+          <a:xfrm flipH="0" flipV="0">
+            <a:off x="171178" y="1683184"/>
+            <a:ext cx="11760694" cy="4713537"/>
+          </a:xfrm>
+          <a:prstGeom prst="rect">
+            <a:avLst/>
+          </a:prstGeom>
+        </p:spPr>
+      </p:pic>
+      <p:sp>
+        <p:nvSpPr>
+          <p:cNvPr id="1901720183" name="Slide Number Placeholder 17"/>
+          <p:cNvSpPr>
+            <a:spLocks noGrp="1"/>
+          </p:cNvSpPr>
+          <p:nvPr>
+            <p:ph type="sldNum" sz="quarter" idx="12"/>
+          </p:nvPr>
+        </p:nvSpPr>
+        <p:spPr bwMode="auto">
+          <a:xfrm>
+            <a:off x="5190394" y="6132834"/>
+            <a:ext cx="952633" cy="365124"/>
+          </a:xfrm>
+        </p:spPr>
+        <p:txBody>
+          <a:bodyPr/>
+          <a:lstStyle/>
+          <a:p>
+            <a:pPr>
+              <a:defRPr/>
+            </a:pPr>
+            <a:fld id="{B17E592C-1673-3DD1-1D73-410B1A13B1D5}" type="slidenum">
+              <a:rPr/>
+              <a:t/>
+            </a:fld>
+            <a:endParaRPr/>
+          </a:p>
+        </p:txBody>
+      </p:sp>
+    </p:spTree>
+  </p:cSld>
+  <p:clrMapOvr>
+    <a:masterClrMapping/>
+  </p:clrMapOvr>
+  <mc:AlternateContent xmlns:mc="http://schemas.openxmlformats.org/markup-compatibility/2006">
+    <mc:Choice xmlns:p159="http://schemas.microsoft.com/office/powerpoint/2015/09/main" xmlns:p14="http://schemas.microsoft.com/office/powerpoint/2010/main" Requires="p159">
+      <p:transition p14:dur="2000" advClick="1"/>
+    </mc:Choice>
+    <mc:Fallback>
+      <p:transition advClick="1"/>
+    </mc:Fallback>
+  </mc:AlternateContent>
+</p:sld>
+</file>
+
+<file path=ppt/slides/slide16.xml><?xml version="1.0" encoding="utf-8"?>
+<p:sld xmlns:a="http://schemas.openxmlformats.org/drawingml/2006/main" xmlns:r="http://schemas.openxmlformats.org/officeDocument/2006/relationships" xmlns:p="http://schemas.openxmlformats.org/presentationml/2006/main" xmlns:m="http://schemas.openxmlformats.org/officeDocument/2006/math" xmlns:w="http://schemas.openxmlformats.org/wordprocessingml/2006/main" xmlns:mc="http://schemas.openxmlformats.org/markup-compatibility/2006" showMasterPhAnim="0" showMasterSp="1" show="1">
+  <p:cSld name="">
+    <p:spTree>
+      <p:nvGrpSpPr>
+        <p:cNvPr id="1" name=""/>
+        <p:cNvGrpSpPr/>
+        <p:nvPr/>
+      </p:nvGrpSpPr>
+      <p:grpSpPr bwMode="auto">
+        <a:xfrm>
+          <a:off x="0" y="0"/>
+          <a:ext cx="0" cy="0"/>
+          <a:chOff x="0" y="0"/>
+          <a:chExt cx="0" cy="0"/>
+        </a:xfrm>
+      </p:grpSpPr>
+      <p:sp>
+        <p:nvSpPr>
+          <p:cNvPr id="208806537" name="Title 1"/>
           <p:cNvSpPr>
             <a:spLocks noGrp="1"/>
           </p:cNvSpPr>
@@ -21360,26 +21881,57 @@
       </p:sp>
       <p:pic>
         <p:nvPicPr>
-          <p:cNvPr id="327202762" name=""/>
+          <p:cNvPr id="646289257" name=""/>
           <p:cNvPicPr>
             <a:picLocks noChangeAspect="1"/>
           </p:cNvPicPr>
           <p:nvPr/>
         </p:nvPicPr>
-        <p:blipFill>
+        <p:blipFill rotWithShape="1">
           <a:blip r:embed="rId3"/>
           <a:stretch/>
         </p:blipFill>
         <p:spPr bwMode="auto">
-          <a:xfrm>
-            <a:off x="617513" y="1506062"/>
-            <a:ext cx="10868024" cy="5229225"/>
+          <a:xfrm flipH="0" flipV="0">
+            <a:off x="705972" y="1751454"/>
+            <a:ext cx="10780048" cy="4700305"/>
           </a:xfrm>
           <a:prstGeom prst="rect">
             <a:avLst/>
           </a:prstGeom>
         </p:spPr>
       </p:pic>
+      <p:sp>
+        <p:nvSpPr>
+          <p:cNvPr id="957419849" name="Slide Number Placeholder 17"/>
+          <p:cNvSpPr>
+            <a:spLocks noGrp="1"/>
+          </p:cNvSpPr>
+          <p:nvPr>
+            <p:ph type="sldNum" sz="quarter" idx="12"/>
+          </p:nvPr>
+        </p:nvSpPr>
+        <p:spPr bwMode="auto">
+          <a:xfrm>
+            <a:off x="5190394" y="6132834"/>
+            <a:ext cx="952633" cy="365124"/>
+          </a:xfrm>
+        </p:spPr>
+        <p:txBody>
+          <a:bodyPr/>
+          <a:lstStyle/>
+          <a:p>
+            <a:pPr>
+              <a:defRPr/>
+            </a:pPr>
+            <a:fld id="{27B6A26C-3A82-86B2-545D-CCDA7C885F76}" type="slidenum">
+              <a:rPr/>
+              <a:t/>
+            </a:fld>
+            <a:endParaRPr/>
+          </a:p>
+        </p:txBody>
+      </p:sp>
     </p:spTree>
   </p:cSld>
   <p:clrMapOvr>
@@ -21415,7 +21967,7 @@
       </p:grpSpPr>
       <p:sp>
         <p:nvSpPr>
-          <p:cNvPr id="727562363" name="Title 1"/>
+          <p:cNvPr id="432811128" name="Title 1"/>
           <p:cNvSpPr>
             <a:spLocks noGrp="1"/>
           </p:cNvSpPr>
@@ -21441,7 +21993,7 @@
       </p:sp>
       <p:sp>
         <p:nvSpPr>
-          <p:cNvPr id="801691775" name=""/>
+          <p:cNvPr id="1789446525" name=""/>
           <p:cNvSpPr txBox="1"/>
           <p:nvPr/>
         </p:nvSpPr>
@@ -21483,7 +22035,7 @@
       </p:sp>
       <p:sp>
         <p:nvSpPr>
-          <p:cNvPr id="189493836" name=""/>
+          <p:cNvPr id="1088452627" name=""/>
           <p:cNvSpPr txBox="1"/>
           <p:nvPr/>
         </p:nvSpPr>
@@ -21511,7 +22063,7 @@
       </p:sp>
       <p:sp>
         <p:nvSpPr>
-          <p:cNvPr id="207314405" name=""/>
+          <p:cNvPr id="72187047" name=""/>
           <p:cNvSpPr txBox="1"/>
           <p:nvPr/>
         </p:nvSpPr>
@@ -21663,7 +22215,7 @@
       </p:sp>
       <p:sp>
         <p:nvSpPr>
-          <p:cNvPr id="821728858" name=""/>
+          <p:cNvPr id="247651146" name=""/>
           <p:cNvSpPr txBox="1"/>
           <p:nvPr/>
         </p:nvSpPr>
@@ -21744,14 +22296,14 @@
       </p:sp>
       <p:sp>
         <p:nvSpPr>
-          <p:cNvPr id="608067348" name=""/>
+          <p:cNvPr id="1139774098" name=""/>
           <p:cNvSpPr txBox="1"/>
           <p:nvPr/>
         </p:nvSpPr>
         <p:spPr bwMode="auto">
           <a:xfrm rot="0" flipH="0" flipV="0">
-            <a:off x="8068357" y="2193890"/>
-            <a:ext cx="2716411" cy="2286359"/>
+            <a:off x="8068356" y="2193889"/>
+            <a:ext cx="2716410" cy="2286359"/>
           </a:xfrm>
           <a:prstGeom prst="rect">
             <a:avLst/>
@@ -21837,7 +22389,7 @@
                 <a:ea typeface="Arial"/>
                 <a:cs typeface="Arial"/>
               </a:rPr>
-              <a:t> UAV-based Road</a:t>
+              <a:t>UAV-based Road</a:t>
             </a:r>
             <a:endParaRPr sz="1800" b="0" i="0" u="none" strike="noStrike" cap="none" spc="0">
               <a:solidFill>
@@ -21988,6 +22540,37 @@
               <a:latin typeface="Arial"/>
               <a:cs typeface="Arial"/>
             </a:endParaRPr>
+          </a:p>
+        </p:txBody>
+      </p:sp>
+      <p:sp>
+        <p:nvSpPr>
+          <p:cNvPr id="1864475383" name="Slide Number Placeholder 17"/>
+          <p:cNvSpPr>
+            <a:spLocks noGrp="1"/>
+          </p:cNvSpPr>
+          <p:nvPr>
+            <p:ph type="sldNum" sz="quarter" idx="12"/>
+          </p:nvPr>
+        </p:nvSpPr>
+        <p:spPr bwMode="auto">
+          <a:xfrm>
+            <a:off x="5190394" y="6132834"/>
+            <a:ext cx="952633" cy="365124"/>
+          </a:xfrm>
+        </p:spPr>
+        <p:txBody>
+          <a:bodyPr/>
+          <a:lstStyle/>
+          <a:p>
+            <a:pPr>
+              <a:defRPr/>
+            </a:pPr>
+            <a:fld id="{7EB17662-CC46-9EEA-E4F0-0BF1757EB7DC}" type="slidenum">
+              <a:rPr/>
+              <a:t/>
+            </a:fld>
+            <a:endParaRPr/>
           </a:p>
         </p:txBody>
       </p:sp>
@@ -22026,7 +22609,7 @@
       </p:grpSpPr>
       <p:sp>
         <p:nvSpPr>
-          <p:cNvPr id="1139471437" name="Title 1"/>
+          <p:cNvPr id="481292833" name="Title 1"/>
           <p:cNvSpPr>
             <a:spLocks noGrp="1"/>
           </p:cNvSpPr>
@@ -22064,7 +22647,7 @@
       </p:sp>
       <p:sp>
         <p:nvSpPr>
-          <p:cNvPr id="1993190230" name=""/>
+          <p:cNvPr id="497949115" name=""/>
           <p:cNvSpPr txBox="1"/>
           <p:nvPr/>
         </p:nvSpPr>
@@ -22106,13 +22689,13 @@
       </p:sp>
       <p:pic>
         <p:nvPicPr>
-          <p:cNvPr id="1089132511" name=""/>
+          <p:cNvPr id="143895814" name=""/>
           <p:cNvPicPr>
             <a:picLocks noChangeAspect="1"/>
           </p:cNvPicPr>
           <p:nvPr/>
         </p:nvPicPr>
-        <p:blipFill>
+        <p:blipFill rotWithShape="1">
           <a:blip r:embed="rId3"/>
           <a:stretch/>
         </p:blipFill>
@@ -22128,13 +22711,13 @@
       </p:pic>
       <p:pic>
         <p:nvPicPr>
-          <p:cNvPr id="894794865" name=""/>
+          <p:cNvPr id="1911909943" name=""/>
           <p:cNvPicPr>
             <a:picLocks noChangeAspect="1"/>
           </p:cNvPicPr>
           <p:nvPr/>
         </p:nvPicPr>
-        <p:blipFill>
+        <p:blipFill rotWithShape="1">
           <a:blip r:embed="rId4"/>
           <a:stretch/>
         </p:blipFill>
@@ -22150,13 +22733,13 @@
       </p:pic>
       <p:pic>
         <p:nvPicPr>
-          <p:cNvPr id="1538836449" name=""/>
+          <p:cNvPr id="1872233059" name=""/>
           <p:cNvPicPr>
             <a:picLocks noChangeAspect="1"/>
           </p:cNvPicPr>
           <p:nvPr/>
         </p:nvPicPr>
-        <p:blipFill>
+        <p:blipFill rotWithShape="1">
           <a:blip r:embed="rId5"/>
           <a:stretch/>
         </p:blipFill>
@@ -22172,7 +22755,7 @@
       </p:pic>
       <p:sp>
         <p:nvSpPr>
-          <p:cNvPr id="1327409754" name=""/>
+          <p:cNvPr id="1629750505" name=""/>
           <p:cNvSpPr/>
           <p:nvPr/>
         </p:nvSpPr>
@@ -22222,7 +22805,7 @@
       </p:sp>
       <p:sp>
         <p:nvSpPr>
-          <p:cNvPr id="301508249" name=""/>
+          <p:cNvPr id="872766806" name=""/>
           <p:cNvSpPr/>
           <p:nvPr/>
         </p:nvSpPr>
@@ -22280,7 +22863,7 @@
       </p:sp>
       <p:sp>
         <p:nvSpPr>
-          <p:cNvPr id="787202257" name=""/>
+          <p:cNvPr id="1263151554" name=""/>
           <p:cNvSpPr/>
           <p:nvPr/>
         </p:nvSpPr>
@@ -22316,7 +22899,7 @@
       </p:sp>
       <p:sp>
         <p:nvSpPr>
-          <p:cNvPr id="741947450" name=""/>
+          <p:cNvPr id="1230465280" name=""/>
           <p:cNvSpPr/>
           <p:nvPr/>
         </p:nvSpPr>
@@ -22352,7 +22935,7 @@
       </p:sp>
       <p:sp>
         <p:nvSpPr>
-          <p:cNvPr id="1590748858" name=""/>
+          <p:cNvPr id="1540575671" name=""/>
           <p:cNvSpPr/>
           <p:nvPr/>
         </p:nvSpPr>
@@ -22388,7 +22971,7 @@
       </p:sp>
       <p:sp>
         <p:nvSpPr>
-          <p:cNvPr id="713035763" name=""/>
+          <p:cNvPr id="1111515353" name=""/>
           <p:cNvSpPr/>
           <p:nvPr/>
         </p:nvSpPr>
@@ -22424,7 +23007,7 @@
       </p:sp>
       <p:sp>
         <p:nvSpPr>
-          <p:cNvPr id="1550151054" name=""/>
+          <p:cNvPr id="963889856" name=""/>
           <p:cNvSpPr/>
           <p:nvPr/>
         </p:nvSpPr>
@@ -22455,6 +23038,37 @@
               <a:t>Image comparison</a:t>
             </a:r>
             <a:endParaRPr sz="1200"/>
+          </a:p>
+        </p:txBody>
+      </p:sp>
+      <p:sp>
+        <p:nvSpPr>
+          <p:cNvPr id="1571613475" name="Slide Number Placeholder 17"/>
+          <p:cNvSpPr>
+            <a:spLocks noGrp="1"/>
+          </p:cNvSpPr>
+          <p:nvPr>
+            <p:ph type="sldNum" sz="quarter" idx="12"/>
+          </p:nvPr>
+        </p:nvSpPr>
+        <p:spPr bwMode="auto">
+          <a:xfrm>
+            <a:off x="5190394" y="6132834"/>
+            <a:ext cx="952633" cy="365124"/>
+          </a:xfrm>
+        </p:spPr>
+        <p:txBody>
+          <a:bodyPr/>
+          <a:lstStyle/>
+          <a:p>
+            <a:pPr>
+              <a:defRPr/>
+            </a:pPr>
+            <a:fld id="{625D058A-33A2-4846-741C-ECFF5EDA33FC}" type="slidenum">
+              <a:rPr/>
+              <a:t/>
+            </a:fld>
+            <a:endParaRPr/>
           </a:p>
         </p:txBody>
       </p:sp>
@@ -22493,7 +23107,7 @@
       </p:grpSpPr>
       <p:sp>
         <p:nvSpPr>
-          <p:cNvPr id="1859172075" name="Title 1"/>
+          <p:cNvPr id="373978376" name="Title 1"/>
           <p:cNvSpPr>
             <a:spLocks noGrp="1"/>
           </p:cNvSpPr>
@@ -22531,7 +23145,7 @@
       </p:sp>
       <p:sp>
         <p:nvSpPr>
-          <p:cNvPr id="696880067" name=""/>
+          <p:cNvPr id="638533729" name=""/>
           <p:cNvSpPr txBox="1"/>
           <p:nvPr/>
         </p:nvSpPr>
@@ -22573,20 +23187,20 @@
       </p:sp>
       <p:pic>
         <p:nvPicPr>
-          <p:cNvPr id="580230194" name=""/>
+          <p:cNvPr id="1002490043" name=""/>
           <p:cNvPicPr>
             <a:picLocks noChangeAspect="1"/>
           </p:cNvPicPr>
           <p:nvPr/>
         </p:nvPicPr>
-        <p:blipFill>
+        <p:blipFill rotWithShape="1">
           <a:blip r:embed="rId3"/>
           <a:stretch/>
         </p:blipFill>
         <p:spPr bwMode="auto">
           <a:xfrm flipH="0" flipV="0">
             <a:off x="1888514" y="1554517"/>
-            <a:ext cx="8145816" cy="4740910"/>
+            <a:ext cx="8145816" cy="4740909"/>
           </a:xfrm>
           <a:prstGeom prst="rect">
             <a:avLst/>
@@ -22595,7 +23209,7 @@
       </p:pic>
       <p:sp>
         <p:nvSpPr>
-          <p:cNvPr id="392676307" name=""/>
+          <p:cNvPr id="108623712" name=""/>
           <p:cNvSpPr/>
           <p:nvPr/>
         </p:nvSpPr>
@@ -22634,6 +23248,37 @@
               <a:t>[2]</a:t>
             </a:r>
             <a:endParaRPr sz="1200"/>
+          </a:p>
+        </p:txBody>
+      </p:sp>
+      <p:sp>
+        <p:nvSpPr>
+          <p:cNvPr id="1128104404" name="Slide Number Placeholder 17"/>
+          <p:cNvSpPr>
+            <a:spLocks noGrp="1"/>
+          </p:cNvSpPr>
+          <p:nvPr>
+            <p:ph type="sldNum" sz="quarter" idx="12"/>
+          </p:nvPr>
+        </p:nvSpPr>
+        <p:spPr bwMode="auto">
+          <a:xfrm>
+            <a:off x="5190394" y="6132834"/>
+            <a:ext cx="952633" cy="365124"/>
+          </a:xfrm>
+        </p:spPr>
+        <p:txBody>
+          <a:bodyPr/>
+          <a:lstStyle/>
+          <a:p>
+            <a:pPr>
+              <a:defRPr/>
+            </a:pPr>
+            <a:fld id="{735DE13D-884A-453D-AACF-D3D352DFAFE4}" type="slidenum">
+              <a:rPr/>
+              <a:t/>
+            </a:fld>
+            <a:endParaRPr/>
           </a:p>
         </p:txBody>
       </p:sp>
@@ -22672,7 +23317,7 @@
       </p:grpSpPr>
       <p:sp>
         <p:nvSpPr>
-          <p:cNvPr id="1804748572" name="Title 1"/>
+          <p:cNvPr id="992084471" name="Title 1"/>
           <p:cNvSpPr>
             <a:spLocks noGrp="1"/>
           </p:cNvSpPr>
@@ -22712,7 +23357,7 @@
       </p:sp>
       <p:sp>
         <p:nvSpPr>
-          <p:cNvPr id="90324534" name="Content Placeholder 2"/>
+          <p:cNvPr id="642460450" name="Content Placeholder 2"/>
           <p:cNvSpPr>
             <a:spLocks noGrp="1"/>
           </p:cNvSpPr>
@@ -22856,7 +23501,7 @@
       </p:sp>
       <p:sp>
         <p:nvSpPr>
-          <p:cNvPr id="304418227" name=""/>
+          <p:cNvPr id="521683744" name=""/>
           <p:cNvSpPr txBox="1"/>
           <p:nvPr/>
         </p:nvSpPr>
@@ -22893,6 +23538,37 @@
               <a:t>DEEC\FCT\UNL - TAPDI</a:t>
             </a:r>
             <a:endParaRPr lang="pt-PT"/>
+          </a:p>
+        </p:txBody>
+      </p:sp>
+      <p:sp>
+        <p:nvSpPr>
+          <p:cNvPr id="625214119" name="Slide Number Placeholder 17"/>
+          <p:cNvSpPr>
+            <a:spLocks noGrp="1"/>
+          </p:cNvSpPr>
+          <p:nvPr>
+            <p:ph type="sldNum" sz="quarter" idx="12"/>
+          </p:nvPr>
+        </p:nvSpPr>
+        <p:spPr bwMode="auto">
+          <a:xfrm>
+            <a:off x="5190394" y="6132834"/>
+            <a:ext cx="952633" cy="365124"/>
+          </a:xfrm>
+        </p:spPr>
+        <p:txBody>
+          <a:bodyPr/>
+          <a:lstStyle/>
+          <a:p>
+            <a:pPr>
+              <a:defRPr/>
+            </a:pPr>
+            <a:fld id="{05CC22F2-8BB1-8E96-2B61-033EB8741BDF}" type="slidenum">
+              <a:rPr/>
+              <a:t/>
+            </a:fld>
+            <a:endParaRPr/>
           </a:p>
         </p:txBody>
       </p:sp>
@@ -22931,7 +23607,7 @@
       </p:grpSpPr>
       <p:sp>
         <p:nvSpPr>
-          <p:cNvPr id="1503344942" name="Title 1"/>
+          <p:cNvPr id="59666499" name="Title 1"/>
           <p:cNvSpPr>
             <a:spLocks noGrp="1"/>
           </p:cNvSpPr>
@@ -22969,13 +23645,13 @@
       </p:sp>
       <p:pic>
         <p:nvPicPr>
-          <p:cNvPr id="1375333975" name=""/>
+          <p:cNvPr id="1341230805" name=""/>
           <p:cNvPicPr>
             <a:picLocks noChangeAspect="1"/>
           </p:cNvPicPr>
           <p:nvPr/>
         </p:nvPicPr>
-        <p:blipFill>
+        <p:blipFill rotWithShape="1">
           <a:blip r:embed="rId3"/>
           <a:stretch/>
         </p:blipFill>
@@ -22991,7 +23667,7 @@
       </p:pic>
       <p:sp>
         <p:nvSpPr>
-          <p:cNvPr id="659033965" name=""/>
+          <p:cNvPr id="1713545969" name=""/>
           <p:cNvSpPr txBox="1"/>
           <p:nvPr/>
         </p:nvSpPr>
@@ -23028,6 +23704,73 @@
               <a:t>DEEC\FCT\UNL - TAPDI</a:t>
             </a:r>
             <a:endParaRPr lang="pt-PT"/>
+          </a:p>
+        </p:txBody>
+      </p:sp>
+      <p:sp>
+        <p:nvSpPr>
+          <p:cNvPr id="234221956" name=""/>
+          <p:cNvSpPr/>
+          <p:nvPr/>
+        </p:nvSpPr>
+        <p:spPr bwMode="auto">
+          <a:xfrm flipH="0" flipV="0">
+            <a:off x="4776882" y="6360870"/>
+            <a:ext cx="7683395" cy="274679"/>
+          </a:xfrm>
+        </p:spPr>
+        <p:txBody>
+          <a:bodyPr rot="0" spcFirstLastPara="0" vertOverflow="overflow" horzOverflow="overflow" vert="horz" wrap="square" lIns="91440" tIns="45720" rIns="91440" bIns="45720" numCol="1" spcCol="0" rtlCol="0" fromWordArt="0" anchor="t" anchorCtr="0" forceAA="0" upright="0" compatLnSpc="1">
+            <a:prstTxWarp prst="textNoShape"/>
+            <a:spAutoFit/>
+          </a:bodyPr>
+          <a:p>
+            <a:pPr>
+              <a:defRPr/>
+            </a:pPr>
+            <a:r>
+              <a:rPr sz="1200" b="0" i="0" u="none">
+                <a:solidFill>
+                  <a:srgbClr val="000000"/>
+                </a:solidFill>
+                <a:latin typeface="Times New Roman"/>
+                <a:ea typeface="Times New Roman"/>
+                <a:cs typeface="Times New Roman"/>
+              </a:rPr>
+              <a:t>Deep Learning Approaches Applied to Remote Sensing Datasets for Road Extraction: A State-Of-The-Art Review [10]</a:t>
+            </a:r>
+            <a:endParaRPr/>
+          </a:p>
+        </p:txBody>
+      </p:sp>
+      <p:sp>
+        <p:nvSpPr>
+          <p:cNvPr id="1530584126" name="Slide Number Placeholder 17"/>
+          <p:cNvSpPr>
+            <a:spLocks noGrp="1"/>
+          </p:cNvSpPr>
+          <p:nvPr>
+            <p:ph type="sldNum" sz="quarter" idx="12"/>
+          </p:nvPr>
+        </p:nvSpPr>
+        <p:spPr bwMode="auto">
+          <a:xfrm>
+            <a:off x="5190394" y="6132834"/>
+            <a:ext cx="952633" cy="365124"/>
+          </a:xfrm>
+        </p:spPr>
+        <p:txBody>
+          <a:bodyPr/>
+          <a:lstStyle/>
+          <a:p>
+            <a:pPr>
+              <a:defRPr/>
+            </a:pPr>
+            <a:fld id="{19FED319-B8F0-20B6-F194-F637BDCCBB73}" type="slidenum">
+              <a:rPr/>
+              <a:t/>
+            </a:fld>
+            <a:endParaRPr/>
           </a:p>
         </p:txBody>
       </p:sp>
@@ -23066,7 +23809,7 @@
       </p:grpSpPr>
       <p:sp>
         <p:nvSpPr>
-          <p:cNvPr id="70777851" name="Title 1"/>
+          <p:cNvPr id="723347010" name="Title 1"/>
           <p:cNvSpPr>
             <a:spLocks noGrp="1"/>
           </p:cNvSpPr>
@@ -23104,7 +23847,7 @@
       </p:sp>
       <p:sp>
         <p:nvSpPr>
-          <p:cNvPr id="674061028" name=""/>
+          <p:cNvPr id="215203140" name=""/>
           <p:cNvSpPr txBox="1"/>
           <p:nvPr/>
         </p:nvSpPr>
@@ -23146,13 +23889,13 @@
       </p:sp>
       <p:pic>
         <p:nvPicPr>
-          <p:cNvPr id="1104756288" name=""/>
+          <p:cNvPr id="813365308" name=""/>
           <p:cNvPicPr>
             <a:picLocks noChangeAspect="1"/>
           </p:cNvPicPr>
           <p:nvPr/>
         </p:nvPicPr>
-        <p:blipFill>
+        <p:blipFill rotWithShape="1">
           <a:blip r:embed="rId3"/>
           <a:stretch/>
         </p:blipFill>
@@ -23168,7 +23911,7 @@
       </p:pic>
       <p:sp>
         <p:nvSpPr>
-          <p:cNvPr id="300285909" name=""/>
+          <p:cNvPr id="1525504328" name=""/>
           <p:cNvSpPr/>
           <p:nvPr/>
         </p:nvSpPr>
@@ -23204,13 +23947,13 @@
       </p:sp>
       <p:pic>
         <p:nvPicPr>
-          <p:cNvPr id="948147650" name=""/>
+          <p:cNvPr id="1770083112" name=""/>
           <p:cNvPicPr>
             <a:picLocks noChangeAspect="1"/>
           </p:cNvPicPr>
           <p:nvPr/>
         </p:nvPicPr>
-        <p:blipFill>
+        <p:blipFill rotWithShape="1">
           <a:blip r:embed="rId4"/>
           <a:stretch/>
         </p:blipFill>
@@ -23226,7 +23969,7 @@
       </p:pic>
       <p:sp>
         <p:nvSpPr>
-          <p:cNvPr id="705271679" name=""/>
+          <p:cNvPr id="1328453116" name=""/>
           <p:cNvSpPr/>
           <p:nvPr/>
         </p:nvSpPr>
@@ -23256,6 +23999,37 @@
               </a:rPr>
               <a:t>Image of Class (Sunset)</a:t>
             </a:r>
+            <a:endParaRPr/>
+          </a:p>
+        </p:txBody>
+      </p:sp>
+      <p:sp>
+        <p:nvSpPr>
+          <p:cNvPr id="1114658758" name="Slide Number Placeholder 17"/>
+          <p:cNvSpPr>
+            <a:spLocks noGrp="1"/>
+          </p:cNvSpPr>
+          <p:nvPr>
+            <p:ph type="sldNum" sz="quarter" idx="12"/>
+          </p:nvPr>
+        </p:nvSpPr>
+        <p:spPr bwMode="auto">
+          <a:xfrm>
+            <a:off x="5190394" y="6132834"/>
+            <a:ext cx="952633" cy="365124"/>
+          </a:xfrm>
+        </p:spPr>
+        <p:txBody>
+          <a:bodyPr/>
+          <a:lstStyle/>
+          <a:p>
+            <a:pPr>
+              <a:defRPr/>
+            </a:pPr>
+            <a:fld id="{BD1E1012-CC9A-06B1-A023-58DE06BC840F}" type="slidenum">
+              <a:rPr/>
+              <a:t/>
+            </a:fld>
             <a:endParaRPr/>
           </a:p>
         </p:txBody>
@@ -23295,7 +24069,7 @@
       </p:grpSpPr>
       <p:sp>
         <p:nvSpPr>
-          <p:cNvPr id="204894946" name="Title 1"/>
+          <p:cNvPr id="1935264395" name="Title 1"/>
           <p:cNvSpPr>
             <a:spLocks noGrp="1"/>
           </p:cNvSpPr>
@@ -23333,13 +24107,13 @@
       </p:sp>
       <p:pic>
         <p:nvPicPr>
-          <p:cNvPr id="1516150033" name=""/>
+          <p:cNvPr id="546398288" name=""/>
           <p:cNvPicPr>
             <a:picLocks noChangeAspect="1"/>
           </p:cNvPicPr>
           <p:nvPr/>
         </p:nvPicPr>
-        <p:blipFill>
+        <p:blipFill rotWithShape="1">
           <a:blip r:embed="rId3"/>
           <a:stretch/>
         </p:blipFill>
@@ -23355,7 +24129,7 @@
       </p:pic>
       <p:sp>
         <p:nvSpPr>
-          <p:cNvPr id="1492152698" name=""/>
+          <p:cNvPr id="972030711" name=""/>
           <p:cNvSpPr txBox="1"/>
           <p:nvPr/>
         </p:nvSpPr>
@@ -23392,6 +24166,73 @@
               <a:t>DEEC\FCT\UNL - TAPDI</a:t>
             </a:r>
             <a:endParaRPr lang="pt-PT"/>
+          </a:p>
+        </p:txBody>
+      </p:sp>
+      <p:sp>
+        <p:nvSpPr>
+          <p:cNvPr id="548258084" name=""/>
+          <p:cNvSpPr/>
+          <p:nvPr/>
+        </p:nvSpPr>
+        <p:spPr bwMode="auto">
+          <a:xfrm flipH="0" flipV="0">
+            <a:off x="4776882" y="6360870"/>
+            <a:ext cx="7683395" cy="274679"/>
+          </a:xfrm>
+        </p:spPr>
+        <p:txBody>
+          <a:bodyPr rot="0" spcFirstLastPara="0" vertOverflow="overflow" horzOverflow="overflow" vert="horz" wrap="square" lIns="91440" tIns="45720" rIns="91440" bIns="45720" numCol="1" spcCol="0" rtlCol="0" fromWordArt="0" anchor="t" anchorCtr="0" forceAA="0" upright="0" compatLnSpc="1">
+            <a:prstTxWarp prst="textNoShape"/>
+            <a:spAutoFit/>
+          </a:bodyPr>
+          <a:p>
+            <a:pPr>
+              <a:defRPr/>
+            </a:pPr>
+            <a:r>
+              <a:rPr sz="1200" b="0" i="0" u="none">
+                <a:solidFill>
+                  <a:srgbClr val="000000"/>
+                </a:solidFill>
+                <a:latin typeface="Times New Roman"/>
+                <a:ea typeface="Times New Roman"/>
+                <a:cs typeface="Times New Roman"/>
+              </a:rPr>
+              <a:t>Deep Learning Approaches Applied to Remote Sensing Datasets for Road Extraction: A State-Of-The-Art Review [10]</a:t>
+            </a:r>
+            <a:endParaRPr/>
+          </a:p>
+        </p:txBody>
+      </p:sp>
+      <p:sp>
+        <p:nvSpPr>
+          <p:cNvPr id="1534001083" name="Slide Number Placeholder 17"/>
+          <p:cNvSpPr>
+            <a:spLocks noGrp="1"/>
+          </p:cNvSpPr>
+          <p:nvPr>
+            <p:ph type="sldNum" sz="quarter" idx="12"/>
+          </p:nvPr>
+        </p:nvSpPr>
+        <p:spPr bwMode="auto">
+          <a:xfrm>
+            <a:off x="5190394" y="6132834"/>
+            <a:ext cx="952633" cy="365124"/>
+          </a:xfrm>
+        </p:spPr>
+        <p:txBody>
+          <a:bodyPr/>
+          <a:lstStyle/>
+          <a:p>
+            <a:pPr>
+              <a:defRPr/>
+            </a:pPr>
+            <a:fld id="{E048ADC5-8E46-FC9D-2607-74749D829D0C}" type="slidenum">
+              <a:rPr/>
+              <a:t/>
+            </a:fld>
+            <a:endParaRPr/>
           </a:p>
         </p:txBody>
       </p:sp>
@@ -23430,7 +24271,7 @@
       </p:grpSpPr>
       <p:sp>
         <p:nvSpPr>
-          <p:cNvPr id="1596986585" name="Title 1"/>
+          <p:cNvPr id="1410390897" name="Title 1"/>
           <p:cNvSpPr>
             <a:spLocks noGrp="1"/>
           </p:cNvSpPr>
@@ -23440,8 +24281,8 @@
         </p:nvSpPr>
         <p:spPr bwMode="auto">
           <a:xfrm flipH="0" flipV="0">
-            <a:off x="2667992" y="851346"/>
-            <a:ext cx="6750077" cy="783347"/>
+            <a:off x="2667991" y="851346"/>
+            <a:ext cx="6750076" cy="783346"/>
           </a:xfrm>
         </p:spPr>
         <p:txBody>
@@ -23454,7 +24295,7 @@
               <a:defRPr/>
             </a:pPr>
             <a:r>
-              <a:rPr lang="pt-PT" sz="3300" b="0" i="0" u="none" strike="noStrike" cap="none" spc="0">
+              <a:rPr lang="en-GB" sz="3300" b="0" i="0" u="none" strike="noStrike" cap="none" spc="0">
                 <a:solidFill>
                   <a:schemeClr val="tx1"/>
                 </a:solidFill>
@@ -23462,7 +24303,7 @@
                 <a:ea typeface="Arial"/>
                 <a:cs typeface="Arial"/>
               </a:rPr>
-              <a:t>DCED</a:t>
+              <a:t>FCN </a:t>
             </a:r>
             <a:r>
               <a:rPr lang="en-GB" sz="3300" b="0" i="0" u="none" strike="noStrike" cap="none" spc="0">
@@ -23473,44 +24314,22 @@
                 <a:ea typeface="Arial"/>
                 <a:cs typeface="Arial"/>
               </a:rPr>
-              <a:t> Models</a:t>
+              <a:t>Models</a:t>
             </a:r>
             <a:endParaRPr/>
           </a:p>
         </p:txBody>
       </p:sp>
-      <p:pic>
-        <p:nvPicPr>
-          <p:cNvPr id="1446793387" name=""/>
-          <p:cNvPicPr>
-            <a:picLocks noChangeAspect="1"/>
-          </p:cNvPicPr>
-          <p:nvPr/>
-        </p:nvPicPr>
-        <p:blipFill>
-          <a:blip r:embed="rId3"/>
-          <a:stretch/>
-        </p:blipFill>
-        <p:spPr bwMode="auto">
-          <a:xfrm flipH="0" flipV="0">
-            <a:off x="2667993" y="1690687"/>
-            <a:ext cx="6856011" cy="4246090"/>
-          </a:xfrm>
-          <a:prstGeom prst="rect">
-            <a:avLst/>
-          </a:prstGeom>
-        </p:spPr>
-      </p:pic>
-      <p:sp>
-        <p:nvSpPr>
-          <p:cNvPr id="1207028176" name=""/>
+      <p:sp>
+        <p:nvSpPr>
+          <p:cNvPr id="1381604042" name=""/>
           <p:cNvSpPr txBox="1"/>
           <p:nvPr/>
         </p:nvSpPr>
         <p:spPr bwMode="auto">
           <a:xfrm rot="0" flipH="0" flipV="0">
-            <a:off x="27059" y="5929672"/>
-            <a:ext cx="2660004" cy="640439"/>
+            <a:off x="27058" y="5929671"/>
+            <a:ext cx="2660004" cy="640438"/>
           </a:xfrm>
           <a:prstGeom prst="rect">
             <a:avLst/>
@@ -23540,6 +24359,133 @@
               <a:t>DEEC\FCT\UNL - TAPDI</a:t>
             </a:r>
             <a:endParaRPr lang="pt-PT"/>
+          </a:p>
+        </p:txBody>
+      </p:sp>
+      <p:pic>
+        <p:nvPicPr>
+          <p:cNvPr id="1634830990" name="">
+            <a:hlinkClick r:id="" action="ppaction://media"/>
+          </p:cNvPr>
+          <p:cNvPicPr>
+            <a:picLocks noChangeAspect="1"/>
+          </p:cNvPicPr>
+          <p:nvPr>
+            <a:videoFile r:link="rId5"/>
+            <p:extLst>
+              <p:ext uri="{DAA4B4D4-6D71-4841-9C94-3DE7FCFB9230}">
+                <p14:media xmlns:p14="http://schemas.microsoft.com/office/powerpoint/2010/main" r:embed="rId4"/>
+              </p:ext>
+            </p:extLst>
+          </p:nvPr>
+        </p:nvPicPr>
+        <p:blipFill rotWithShape="1">
+          <a:blip r:embed="rId3"/>
+          <a:stretch/>
+        </p:blipFill>
+        <p:spPr bwMode="auto">
+          <a:xfrm flipH="0" flipV="0">
+            <a:off x="1861908" y="1650129"/>
+            <a:ext cx="8933130" cy="4279542"/>
+          </a:xfrm>
+          <a:prstGeom prst="rect">
+            <a:avLst/>
+          </a:prstGeom>
+        </p:spPr>
+      </p:pic>
+      <p:sp>
+        <p:nvSpPr>
+          <p:cNvPr id="1396939597" name=""/>
+          <p:cNvSpPr/>
+          <p:nvPr/>
+        </p:nvSpPr>
+        <p:spPr bwMode="auto">
+          <a:xfrm flipH="0" flipV="0">
+            <a:off x="6825825" y="6112550"/>
+            <a:ext cx="5363010" cy="457560"/>
+          </a:xfrm>
+        </p:spPr>
+        <p:txBody>
+          <a:bodyPr rot="0" spcFirstLastPara="0" vertOverflow="overflow" horzOverflow="overflow" vert="horz" wrap="square" lIns="91440" tIns="45720" rIns="91440" bIns="45720" numCol="1" spcCol="0" rtlCol="0" fromWordArt="0" anchor="t" anchorCtr="0" forceAA="0" upright="0" compatLnSpc="1">
+            <a:prstTxWarp prst="textNoShape"/>
+            <a:spAutoFit/>
+          </a:bodyPr>
+          <a:p>
+            <a:pPr>
+              <a:defRPr/>
+            </a:pPr>
+            <a:r>
+              <a:rPr sz="1200" b="0" i="0" u="none">
+                <a:solidFill>
+                  <a:schemeClr val="tx1"/>
+                </a:solidFill>
+                <a:latin typeface="Arial"/>
+                <a:ea typeface="Arial"/>
+                <a:cs typeface="Arial"/>
+              </a:rPr>
+              <a:t>FCN-8s pretrained on Pascal-Context, used in farming environment. (1/2)</a:t>
+            </a:r>
+            <a:endParaRPr sz="1200" b="0" i="0" u="none">
+              <a:solidFill>
+                <a:schemeClr val="tx1"/>
+              </a:solidFill>
+              <a:latin typeface="Arial"/>
+              <a:ea typeface="Arial"/>
+              <a:cs typeface="Arial"/>
+            </a:endParaRPr>
+          </a:p>
+          <a:p>
+            <a:pPr>
+              <a:defRPr/>
+            </a:pPr>
+            <a:r>
+              <a:rPr lang="en-GB" sz="1200" b="0" i="0" u="sng" strike="noStrike" cap="none" spc="0">
+                <a:solidFill>
+                  <a:schemeClr val="tx1"/>
+                </a:solidFill>
+                <a:latin typeface="Arial"/>
+                <a:ea typeface="Arial"/>
+                <a:cs typeface="Arial"/>
+                <a:hlinkClick r:id="rId6" tooltip=""/>
+              </a:rPr>
+              <a:t>https://www.youtube.com/watch?v=KMFNNfGLIGg</a:t>
+            </a:r>
+            <a:endParaRPr b="0">
+              <a:solidFill>
+                <a:schemeClr val="tx1"/>
+              </a:solidFill>
+            </a:endParaRPr>
+          </a:p>
+        </p:txBody>
+      </p:sp>
+      <p:sp>
+        <p:nvSpPr>
+          <p:cNvPr id="1837223704" name="Slide Number Placeholder 17"/>
+          <p:cNvSpPr>
+            <a:spLocks noGrp="1"/>
+          </p:cNvSpPr>
+          <p:nvPr>
+            <p:ph type="sldNum" sz="quarter" idx="12"/>
+          </p:nvPr>
+        </p:nvSpPr>
+        <p:spPr bwMode="auto">
+          <a:xfrm>
+            <a:off x="5190394" y="6132834"/>
+            <a:ext cx="952633" cy="365124"/>
+          </a:xfrm>
+        </p:spPr>
+        <p:txBody>
+          <a:bodyPr/>
+          <a:lstStyle/>
+          <a:p>
+            <a:pPr>
+              <a:defRPr/>
+            </a:pPr>
+            <a:fld id="{5A06C892-B2BC-FC01-07C6-A1C04B36E834}" type="slidenum">
+              <a:rPr/>
+              <a:t/>
+            </a:fld>
+            <a:endParaRPr/>
           </a:p>
         </p:txBody>
       </p:sp>

</xml_diff>